<commit_message>
Update final project presentation - dumb formatting
</commit_message>
<xml_diff>
--- a/Docs/Final_Project_Presentation_Draft.pptx
+++ b/Docs/Final_Project_Presentation_Draft.pptx
@@ -2239,7 +2239,7 @@
         </p:nvSpPr>
         <p:spPr>
           <a:xfrm>
-            <a:off x="0" y="118200"/>
+            <a:off x="305" y="0"/>
             <a:ext cx="12191695" cy="6858000"/>
           </a:xfrm>
           <a:prstGeom prst="rect">
@@ -4129,7 +4129,9 @@
             <a:avLst/>
           </a:prstGeom>
           <a:noFill/>
-          <a:ln/>
+          <a:ln>
+            <a:noFill/>
+          </a:ln>
         </p:spPr>
         <p:txBody>
           <a:bodyPr wrap="square" lIns="0" tIns="0" rIns="0" bIns="0" rtlCol="0" anchor="t">
@@ -6412,6 +6414,78 @@
           </a:p>
         </p:txBody>
       </p:sp>
+      <p:cxnSp>
+        <p:nvCxnSpPr>
+          <p:cNvPr id="10" name="Straight Connector 9">
+            <a:extLst>
+              <a:ext uri="{FF2B5EF4-FFF2-40B4-BE49-F238E27FC236}">
+                <a16:creationId xmlns:a16="http://schemas.microsoft.com/office/drawing/2014/main" id="{2EB6E24A-0E98-1A23-DB40-8F94F5FCB2E8}"/>
+              </a:ext>
+            </a:extLst>
+          </p:cNvPr>
+          <p:cNvCxnSpPr/>
+          <p:nvPr/>
+        </p:nvCxnSpPr>
+        <p:spPr>
+          <a:xfrm>
+            <a:off x="731520" y="1078992"/>
+            <a:ext cx="0" cy="2923251"/>
+          </a:xfrm>
+          <a:prstGeom prst="line">
+            <a:avLst/>
+          </a:prstGeom>
+        </p:spPr>
+        <p:style>
+          <a:lnRef idx="1">
+            <a:schemeClr val="accent1"/>
+          </a:lnRef>
+          <a:fillRef idx="0">
+            <a:schemeClr val="accent1"/>
+          </a:fillRef>
+          <a:effectRef idx="0">
+            <a:schemeClr val="accent1"/>
+          </a:effectRef>
+          <a:fontRef idx="minor">
+            <a:schemeClr val="tx1"/>
+          </a:fontRef>
+        </p:style>
+      </p:cxnSp>
+      <p:cxnSp>
+        <p:nvCxnSpPr>
+          <p:cNvPr id="15" name="Straight Connector 14">
+            <a:extLst>
+              <a:ext uri="{FF2B5EF4-FFF2-40B4-BE49-F238E27FC236}">
+                <a16:creationId xmlns:a16="http://schemas.microsoft.com/office/drawing/2014/main" id="{2B3A0584-80A7-C44B-0779-FDD7115C2F0A}"/>
+              </a:ext>
+            </a:extLst>
+          </p:cNvPr>
+          <p:cNvCxnSpPr/>
+          <p:nvPr/>
+        </p:nvCxnSpPr>
+        <p:spPr>
+          <a:xfrm>
+            <a:off x="477371" y="1307592"/>
+            <a:ext cx="1900069" cy="0"/>
+          </a:xfrm>
+          <a:prstGeom prst="line">
+            <a:avLst/>
+          </a:prstGeom>
+        </p:spPr>
+        <p:style>
+          <a:lnRef idx="1">
+            <a:schemeClr val="accent1"/>
+          </a:lnRef>
+          <a:fillRef idx="0">
+            <a:schemeClr val="accent1"/>
+          </a:fillRef>
+          <a:effectRef idx="0">
+            <a:schemeClr val="accent1"/>
+          </a:effectRef>
+          <a:fontRef idx="minor">
+            <a:schemeClr val="tx1"/>
+          </a:fontRef>
+        </p:style>
+      </p:cxnSp>
     </p:spTree>
   </p:cSld>
   <p:clrMapOvr>
@@ -10757,28 +10831,28 @@
           <p:nvPr>
             <p:extLst>
               <p:ext uri="{D42A27DB-BD31-4B8C-83A1-F6EECF244321}">
-                <p14:modId xmlns:p14="http://schemas.microsoft.com/office/powerpoint/2010/main" val="3342296781"/>
+                <p14:modId xmlns:p14="http://schemas.microsoft.com/office/powerpoint/2010/main" val="1964485884"/>
               </p:ext>
             </p:extLst>
           </p:nvPr>
         </p:nvGraphicFramePr>
         <p:xfrm>
-          <a:off x="694943" y="2830817"/>
-          <a:ext cx="4434167" cy="1713738"/>
+          <a:off x="731519" y="2830817"/>
+          <a:ext cx="4397591" cy="1713738"/>
         </p:xfrm>
         <a:graphic>
           <a:graphicData uri="http://schemas.openxmlformats.org/drawingml/2006/table">
             <a:tbl>
               <a:tblPr/>
               <a:tblGrid>
-                <a:gridCol w="1081504">
+                <a:gridCol w="1072583">
                   <a:extLst>
                     <a:ext uri="{9D8B030D-6E8A-4147-A177-3AD203B41FA5}">
                       <a16:colId xmlns:a16="http://schemas.microsoft.com/office/drawing/2014/main" val="20000"/>
                     </a:ext>
                   </a:extLst>
                 </a:gridCol>
-                <a:gridCol w="3352663">
+                <a:gridCol w="3325008">
                   <a:extLst>
                     <a:ext uri="{9D8B030D-6E8A-4147-A177-3AD203B41FA5}">
                       <a16:colId xmlns:a16="http://schemas.microsoft.com/office/drawing/2014/main" val="20001"/>
@@ -13040,28 +13114,28 @@
           <p:nvPr>
             <p:extLst>
               <p:ext uri="{D42A27DB-BD31-4B8C-83A1-F6EECF244321}">
-                <p14:modId xmlns:p14="http://schemas.microsoft.com/office/powerpoint/2010/main" val="3810333205"/>
+                <p14:modId xmlns:p14="http://schemas.microsoft.com/office/powerpoint/2010/main" val="606077971"/>
               </p:ext>
             </p:extLst>
           </p:nvPr>
         </p:nvGraphicFramePr>
         <p:xfrm>
-          <a:off x="694943" y="2836948"/>
-          <a:ext cx="4434166" cy="1872996"/>
+          <a:off x="731519" y="2836948"/>
+          <a:ext cx="4397590" cy="1872996"/>
         </p:xfrm>
         <a:graphic>
           <a:graphicData uri="http://schemas.openxmlformats.org/drawingml/2006/table">
             <a:tbl>
               <a:tblPr/>
               <a:tblGrid>
-                <a:gridCol w="1081503">
+                <a:gridCol w="1072582">
                   <a:extLst>
                     <a:ext uri="{9D8B030D-6E8A-4147-A177-3AD203B41FA5}">
                       <a16:colId xmlns:a16="http://schemas.microsoft.com/office/drawing/2014/main" val="20000"/>
                     </a:ext>
                   </a:extLst>
                 </a:gridCol>
-                <a:gridCol w="3352663">
+                <a:gridCol w="3325008">
                   <a:extLst>
                     <a:ext uri="{9D8B030D-6E8A-4147-A177-3AD203B41FA5}">
                       <a16:colId xmlns:a16="http://schemas.microsoft.com/office/drawing/2014/main" val="20001"/>
@@ -22464,28 +22538,28 @@
           <p:nvPr>
             <p:extLst>
               <p:ext uri="{D42A27DB-BD31-4B8C-83A1-F6EECF244321}">
-                <p14:modId xmlns:p14="http://schemas.microsoft.com/office/powerpoint/2010/main" val="3126877790"/>
+                <p14:modId xmlns:p14="http://schemas.microsoft.com/office/powerpoint/2010/main" val="4227911563"/>
               </p:ext>
             </p:extLst>
           </p:nvPr>
         </p:nvGraphicFramePr>
         <p:xfrm>
-          <a:off x="694942" y="2655680"/>
-          <a:ext cx="4434151" cy="1713738"/>
+          <a:off x="743871" y="2655680"/>
+          <a:ext cx="4385222" cy="1821180"/>
         </p:xfrm>
         <a:graphic>
           <a:graphicData uri="http://schemas.openxmlformats.org/drawingml/2006/table">
             <a:tbl>
               <a:tblPr/>
               <a:tblGrid>
-                <a:gridCol w="1058235">
+                <a:gridCol w="1046558">
                   <a:extLst>
                     <a:ext uri="{9D8B030D-6E8A-4147-A177-3AD203B41FA5}">
                       <a16:colId xmlns:a16="http://schemas.microsoft.com/office/drawing/2014/main" val="20000"/>
                     </a:ext>
                   </a:extLst>
                 </a:gridCol>
-                <a:gridCol w="3375916">
+                <a:gridCol w="3338664">
                   <a:extLst>
                     <a:ext uri="{9D8B030D-6E8A-4147-A177-3AD203B41FA5}">
                       <a16:colId xmlns:a16="http://schemas.microsoft.com/office/drawing/2014/main" val="20001"/>
@@ -23777,14 +23851,16 @@
         </p:nvSpPr>
         <p:spPr>
           <a:xfrm>
-            <a:off x="777240" y="1325880"/>
+            <a:off x="731520" y="1304947"/>
             <a:ext cx="1828800" cy="182880"/>
           </a:xfrm>
           <a:prstGeom prst="rect">
             <a:avLst/>
           </a:prstGeom>
           <a:noFill/>
-          <a:ln/>
+          <a:ln>
+            <a:noFill/>
+          </a:ln>
         </p:spPr>
         <p:txBody>
           <a:bodyPr wrap="square" lIns="0" tIns="0" rIns="0" bIns="0" rtlCol="0" anchor="t">
@@ -23827,14 +23903,16 @@
         </p:nvSpPr>
         <p:spPr>
           <a:xfrm>
-            <a:off x="777239" y="1600200"/>
-            <a:ext cx="5013961" cy="658846"/>
+            <a:off x="731521" y="1600200"/>
+            <a:ext cx="5059680" cy="658846"/>
           </a:xfrm>
           <a:prstGeom prst="rect">
             <a:avLst/>
           </a:prstGeom>
           <a:noFill/>
-          <a:ln/>
+          <a:ln>
+            <a:noFill/>
+          </a:ln>
         </p:spPr>
         <p:txBody>
           <a:bodyPr wrap="square" lIns="0" tIns="0" rIns="0" bIns="0" rtlCol="0" anchor="t">
@@ -24054,14 +24132,16 @@
         </p:nvSpPr>
         <p:spPr>
           <a:xfrm>
-            <a:off x="713232" y="1307592"/>
+            <a:off x="731520" y="1307591"/>
             <a:ext cx="1097280" cy="164592"/>
           </a:xfrm>
           <a:prstGeom prst="rect">
             <a:avLst/>
           </a:prstGeom>
           <a:noFill/>
-          <a:ln/>
+          <a:ln>
+            <a:noFill/>
+          </a:ln>
         </p:spPr>
         <p:txBody>
           <a:bodyPr wrap="square" lIns="0" tIns="0" rIns="0" bIns="0" rtlCol="0" anchor="t">
@@ -24098,14 +24178,16 @@
         </p:nvSpPr>
         <p:spPr>
           <a:xfrm>
-            <a:off x="713232" y="1554480"/>
-            <a:ext cx="5303520" cy="457200"/>
+            <a:off x="731520" y="1601916"/>
+            <a:ext cx="5285232" cy="457200"/>
           </a:xfrm>
           <a:prstGeom prst="rect">
             <a:avLst/>
           </a:prstGeom>
           <a:noFill/>
-          <a:ln/>
+          <a:ln>
+            <a:noFill/>
+          </a:ln>
         </p:spPr>
         <p:txBody>
           <a:bodyPr wrap="square" lIns="0" tIns="0" rIns="0" bIns="0" rtlCol="0" anchor="t">
@@ -24138,8 +24220,8 @@
         </p:nvSpPr>
         <p:spPr>
           <a:xfrm>
-            <a:off x="713232" y="2321628"/>
-            <a:ext cx="1645920" cy="164592"/>
+            <a:off x="731520" y="2321628"/>
+            <a:ext cx="1627632" cy="164592"/>
           </a:xfrm>
           <a:prstGeom prst="rect">
             <a:avLst/>
@@ -24178,8 +24260,8 @@
         </p:nvSpPr>
         <p:spPr>
           <a:xfrm>
-            <a:off x="713232" y="4342874"/>
-            <a:ext cx="1005840" cy="146304"/>
+            <a:off x="731520" y="4326060"/>
+            <a:ext cx="1002270" cy="146304"/>
           </a:xfrm>
           <a:prstGeom prst="rect">
             <a:avLst/>
@@ -24218,8 +24300,8 @@
         </p:nvSpPr>
         <p:spPr>
           <a:xfrm>
-            <a:off x="713232" y="4568476"/>
-            <a:ext cx="5152109" cy="1281482"/>
+            <a:off x="731520" y="4568476"/>
+            <a:ext cx="5133821" cy="1281482"/>
           </a:xfrm>
           <a:prstGeom prst="rect">
             <a:avLst/>
@@ -25286,35 +25368,35 @@
           <p:nvPr>
             <p:extLst>
               <p:ext uri="{D42A27DB-BD31-4B8C-83A1-F6EECF244321}">
-                <p14:modId xmlns:p14="http://schemas.microsoft.com/office/powerpoint/2010/main" val="3771119343"/>
+                <p14:modId xmlns:p14="http://schemas.microsoft.com/office/powerpoint/2010/main" val="3406380302"/>
               </p:ext>
             </p:extLst>
           </p:nvPr>
         </p:nvGraphicFramePr>
         <p:xfrm>
-          <a:off x="694942" y="2655678"/>
-          <a:ext cx="5152110" cy="1386496"/>
+          <a:off x="731520" y="2655678"/>
+          <a:ext cx="5115532" cy="1386496"/>
         </p:xfrm>
         <a:graphic>
           <a:graphicData uri="http://schemas.openxmlformats.org/drawingml/2006/table">
             <a:tbl>
               <a:tblPr/>
               <a:tblGrid>
-                <a:gridCol w="985577">
+                <a:gridCol w="978580">
                   <a:extLst>
                     <a:ext uri="{9D8B030D-6E8A-4147-A177-3AD203B41FA5}">
                       <a16:colId xmlns:a16="http://schemas.microsoft.com/office/drawing/2014/main" val="20000"/>
                     </a:ext>
                   </a:extLst>
                 </a:gridCol>
-                <a:gridCol w="2693773">
+                <a:gridCol w="2674648">
                   <a:extLst>
                     <a:ext uri="{9D8B030D-6E8A-4147-A177-3AD203B41FA5}">
                       <a16:colId xmlns:a16="http://schemas.microsoft.com/office/drawing/2014/main" val="20001"/>
                     </a:ext>
                   </a:extLst>
                 </a:gridCol>
-                <a:gridCol w="1472760">
+                <a:gridCol w="1462304">
                   <a:extLst>
                     <a:ext uri="{9D8B030D-6E8A-4147-A177-3AD203B41FA5}">
                       <a16:colId xmlns:a16="http://schemas.microsoft.com/office/drawing/2014/main" val="35711274"/>
@@ -27108,14 +27190,16 @@
         </p:nvSpPr>
         <p:spPr>
           <a:xfrm>
-            <a:off x="777240" y="1325880"/>
+            <a:off x="731520" y="1307591"/>
             <a:ext cx="1828800" cy="182880"/>
           </a:xfrm>
           <a:prstGeom prst="rect">
             <a:avLst/>
           </a:prstGeom>
           <a:noFill/>
-          <a:ln/>
+          <a:ln>
+            <a:noFill/>
+          </a:ln>
         </p:spPr>
         <p:txBody>
           <a:bodyPr wrap="square" lIns="0" tIns="0" rIns="0" bIns="0" rtlCol="0" anchor="t">
@@ -27158,18 +27242,20 @@
         </p:nvSpPr>
         <p:spPr>
           <a:xfrm>
-            <a:off x="777240" y="1600200"/>
-            <a:ext cx="4691231" cy="411480"/>
+            <a:off x="737816" y="1600200"/>
+            <a:ext cx="4730655" cy="411480"/>
           </a:xfrm>
           <a:prstGeom prst="rect">
             <a:avLst/>
           </a:prstGeom>
           <a:noFill/>
-          <a:ln/>
+          <a:ln>
+            <a:noFill/>
+          </a:ln>
         </p:spPr>
         <p:txBody>
           <a:bodyPr wrap="square" lIns="0" tIns="0" rIns="0" bIns="0" rtlCol="0" anchor="t">
-            <a:normAutofit fontScale="70000" lnSpcReduction="20000"/>
+            <a:normAutofit/>
           </a:bodyPr>
           <a:lstStyle/>
           <a:p>
@@ -27180,7 +27266,7 @@
               <a:buNone/>
             </a:pPr>
             <a:r>
-              <a:rPr lang="en-US" sz="1900" dirty="0">
+              <a:rPr lang="en-US" sz="1200" dirty="0">
                 <a:solidFill>
                   <a:srgbClr val="1F2528"/>
                 </a:solidFill>
@@ -27190,7 +27276,7 @@
               </a:rPr>
               <a:t>From local spectrogram patterns to temporal sequence modeling – LSTM baseline defined, Design of Experiments created to vary 4 factors</a:t>
             </a:r>
-            <a:endParaRPr lang="en-US" sz="1900" dirty="0"/>
+            <a:endParaRPr lang="en-US" sz="1200" dirty="0"/>
           </a:p>
         </p:txBody>
       </p:sp>
@@ -27567,8 +27653,8 @@
         </p:nvSpPr>
         <p:spPr>
           <a:xfrm>
-            <a:off x="780690" y="2051104"/>
-            <a:ext cx="5440680" cy="164592"/>
+            <a:off x="737816" y="2051104"/>
+            <a:ext cx="4651038" cy="164592"/>
           </a:xfrm>
           <a:prstGeom prst="rect">
             <a:avLst/>
@@ -31227,14 +31313,16 @@
         </p:nvSpPr>
         <p:spPr>
           <a:xfrm>
-            <a:off x="777240" y="1325880"/>
+            <a:off x="731520" y="1307591"/>
             <a:ext cx="1828800" cy="182880"/>
           </a:xfrm>
           <a:prstGeom prst="rect">
             <a:avLst/>
           </a:prstGeom>
           <a:noFill/>
-          <a:ln/>
+          <a:ln>
+            <a:noFill/>
+          </a:ln>
         </p:spPr>
         <p:txBody>
           <a:bodyPr wrap="square" lIns="0" tIns="0" rIns="0" bIns="0" rtlCol="0" anchor="t">
@@ -31277,8 +31365,8 @@
         </p:nvSpPr>
         <p:spPr>
           <a:xfrm>
-            <a:off x="777240" y="1600199"/>
-            <a:ext cx="4691231" cy="537127"/>
+            <a:off x="731520" y="1603618"/>
+            <a:ext cx="4691231" cy="515419"/>
           </a:xfrm>
           <a:prstGeom prst="rect">
             <a:avLst/>
@@ -31575,7 +31663,7 @@
         </p:spPr>
         <p:txBody>
           <a:bodyPr wrap="square" lIns="0" tIns="0" rIns="0" bIns="0" rtlCol="0" anchor="t">
-            <a:normAutofit/>
+            <a:noAutofit/>
           </a:bodyPr>
           <a:lstStyle/>
           <a:p>
@@ -31586,7 +31674,7 @@
               <a:buNone/>
             </a:pPr>
             <a:r>
-              <a:rPr lang="en-US" sz="1130" dirty="0">
+              <a:rPr lang="en-US" sz="1200" dirty="0">
                 <a:solidFill>
                   <a:schemeClr val="tx1">
                     <a:lumMod val="75000"/>
@@ -31600,7 +31688,7 @@
               <a:t>LSTM architectures performed </a:t>
             </a:r>
             <a:r>
-              <a:rPr lang="en-US" sz="1130" b="1" dirty="0">
+              <a:rPr lang="en-US" sz="1200" b="1" dirty="0">
                 <a:solidFill>
                   <a:schemeClr val="tx1">
                     <a:lumMod val="75000"/>
@@ -31614,7 +31702,7 @@
               <a:t>worse</a:t>
             </a:r>
             <a:r>
-              <a:rPr lang="en-US" sz="1130" dirty="0">
+              <a:rPr lang="en-US" sz="1200" dirty="0">
                 <a:solidFill>
                   <a:schemeClr val="tx1">
                     <a:lumMod val="75000"/>
@@ -31636,7 +31724,7 @@
               <a:buNone/>
             </a:pPr>
             <a:r>
-              <a:rPr lang="en-US" sz="1130" dirty="0">
+              <a:rPr lang="en-US" sz="1200" dirty="0">
                 <a:solidFill>
                   <a:schemeClr val="tx1">
                     <a:lumMod val="75000"/>
@@ -31656,7 +31744,7 @@
               <a:buChar char="•"/>
             </a:pPr>
             <a:r>
-              <a:rPr lang="en-US" sz="1130" dirty="0">
+              <a:rPr lang="en-US" sz="1200" dirty="0">
                 <a:solidFill>
                   <a:schemeClr val="tx1">
                     <a:lumMod val="75000"/>
@@ -31676,7 +31764,7 @@
               <a:buChar char="•"/>
             </a:pPr>
             <a:r>
-              <a:rPr lang="en-US" sz="1130" dirty="0">
+              <a:rPr lang="en-US" sz="1200" dirty="0">
                 <a:solidFill>
                   <a:schemeClr val="tx1">
                     <a:lumMod val="75000"/>
@@ -31696,7 +31784,7 @@
               <a:buChar char="•"/>
             </a:pPr>
             <a:r>
-              <a:rPr lang="en-US" sz="1130" dirty="0">
+              <a:rPr lang="en-US" sz="1200" dirty="0">
                 <a:solidFill>
                   <a:schemeClr val="tx1">
                     <a:lumMod val="75000"/>
@@ -31723,8 +31811,8 @@
         </p:nvSpPr>
         <p:spPr>
           <a:xfrm>
-            <a:off x="780829" y="2163539"/>
-            <a:ext cx="5440680" cy="164592"/>
+            <a:off x="731520" y="2163539"/>
+            <a:ext cx="5489989" cy="164592"/>
           </a:xfrm>
           <a:prstGeom prst="rect">
             <a:avLst/>
@@ -31770,28 +31858,28 @@
           <p:nvPr>
             <p:extLst>
               <p:ext uri="{D42A27DB-BD31-4B8C-83A1-F6EECF244321}">
-                <p14:modId xmlns:p14="http://schemas.microsoft.com/office/powerpoint/2010/main" val="3222696318"/>
+                <p14:modId xmlns:p14="http://schemas.microsoft.com/office/powerpoint/2010/main" val="989276497"/>
               </p:ext>
             </p:extLst>
           </p:nvPr>
         </p:nvGraphicFramePr>
         <p:xfrm>
-          <a:off x="777241" y="2354342"/>
-          <a:ext cx="4434165" cy="1821180"/>
+          <a:off x="731521" y="2354342"/>
+          <a:ext cx="4479886" cy="1821180"/>
         </p:xfrm>
         <a:graphic>
           <a:graphicData uri="http://schemas.openxmlformats.org/drawingml/2006/table">
             <a:tbl>
               <a:tblPr/>
               <a:tblGrid>
-                <a:gridCol w="1028428">
+                <a:gridCol w="1039032">
                   <a:extLst>
                     <a:ext uri="{9D8B030D-6E8A-4147-A177-3AD203B41FA5}">
                       <a16:colId xmlns:a16="http://schemas.microsoft.com/office/drawing/2014/main" val="20000"/>
                     </a:ext>
                   </a:extLst>
                 </a:gridCol>
-                <a:gridCol w="3405737">
+                <a:gridCol w="3440854">
                   <a:extLst>
                     <a:ext uri="{9D8B030D-6E8A-4147-A177-3AD203B41FA5}">
                       <a16:colId xmlns:a16="http://schemas.microsoft.com/office/drawing/2014/main" val="20001"/>
@@ -32850,35 +32938,35 @@
           <p:nvPr>
             <p:extLst>
               <p:ext uri="{D42A27DB-BD31-4B8C-83A1-F6EECF244321}">
-                <p14:modId xmlns:p14="http://schemas.microsoft.com/office/powerpoint/2010/main" val="2695269915"/>
+                <p14:modId xmlns:p14="http://schemas.microsoft.com/office/powerpoint/2010/main" val="2921529174"/>
               </p:ext>
             </p:extLst>
           </p:nvPr>
         </p:nvGraphicFramePr>
         <p:xfrm>
-          <a:off x="777240" y="4288669"/>
-          <a:ext cx="4434166" cy="1158240"/>
+          <a:off x="731520" y="4288669"/>
+          <a:ext cx="4479886" cy="1158240"/>
         </p:xfrm>
         <a:graphic>
           <a:graphicData uri="http://schemas.openxmlformats.org/drawingml/2006/table">
             <a:tbl>
               <a:tblPr/>
               <a:tblGrid>
-                <a:gridCol w="1679858">
+                <a:gridCol w="1697179">
                   <a:extLst>
                     <a:ext uri="{9D8B030D-6E8A-4147-A177-3AD203B41FA5}">
                       <a16:colId xmlns:a16="http://schemas.microsoft.com/office/drawing/2014/main" val="20000"/>
                     </a:ext>
                   </a:extLst>
                 </a:gridCol>
-                <a:gridCol w="1232611">
+                <a:gridCol w="1245320">
                   <a:extLst>
                     <a:ext uri="{9D8B030D-6E8A-4147-A177-3AD203B41FA5}">
                       <a16:colId xmlns:a16="http://schemas.microsoft.com/office/drawing/2014/main" val="20001"/>
                     </a:ext>
                   </a:extLst>
                 </a:gridCol>
-                <a:gridCol w="1521697">
+                <a:gridCol w="1537387">
                   <a:extLst>
                     <a:ext uri="{9D8B030D-6E8A-4147-A177-3AD203B41FA5}">
                       <a16:colId xmlns:a16="http://schemas.microsoft.com/office/drawing/2014/main" val="3678863950"/>
@@ -33901,56 +33989,56 @@
           <p:nvPr>
             <p:extLst>
               <p:ext uri="{D42A27DB-BD31-4B8C-83A1-F6EECF244321}">
-                <p14:modId xmlns:p14="http://schemas.microsoft.com/office/powerpoint/2010/main" val="110652709"/>
+                <p14:modId xmlns:p14="http://schemas.microsoft.com/office/powerpoint/2010/main" val="3987419374"/>
               </p:ext>
             </p:extLst>
           </p:nvPr>
         </p:nvGraphicFramePr>
         <p:xfrm>
-          <a:off x="777242" y="5560056"/>
-          <a:ext cx="4434164" cy="600456"/>
+          <a:off x="731522" y="5560056"/>
+          <a:ext cx="4479884" cy="600456"/>
         </p:xfrm>
         <a:graphic>
           <a:graphicData uri="http://schemas.openxmlformats.org/drawingml/2006/table">
             <a:tbl>
               <a:tblPr/>
               <a:tblGrid>
-                <a:gridCol w="502108">
+                <a:gridCol w="507285">
                   <a:extLst>
                     <a:ext uri="{9D8B030D-6E8A-4147-A177-3AD203B41FA5}">
                       <a16:colId xmlns:a16="http://schemas.microsoft.com/office/drawing/2014/main" val="20000"/>
                     </a:ext>
                   </a:extLst>
                 </a:gridCol>
-                <a:gridCol w="676656">
+                <a:gridCol w="683633">
                   <a:extLst>
                     <a:ext uri="{9D8B030D-6E8A-4147-A177-3AD203B41FA5}">
                       <a16:colId xmlns:a16="http://schemas.microsoft.com/office/drawing/2014/main" val="20001"/>
                     </a:ext>
                   </a:extLst>
                 </a:gridCol>
-                <a:gridCol w="610820">
+                <a:gridCol w="617118">
                   <a:extLst>
                     <a:ext uri="{9D8B030D-6E8A-4147-A177-3AD203B41FA5}">
                       <a16:colId xmlns:a16="http://schemas.microsoft.com/office/drawing/2014/main" val="3678863950"/>
                     </a:ext>
                   </a:extLst>
                 </a:gridCol>
-                <a:gridCol w="519379">
+                <a:gridCol w="524734">
                   <a:extLst>
                     <a:ext uri="{9D8B030D-6E8A-4147-A177-3AD203B41FA5}">
                       <a16:colId xmlns:a16="http://schemas.microsoft.com/office/drawing/2014/main" val="2782421059"/>
                     </a:ext>
                   </a:extLst>
                 </a:gridCol>
-                <a:gridCol w="705917">
+                <a:gridCol w="713196">
                   <a:extLst>
                     <a:ext uri="{9D8B030D-6E8A-4147-A177-3AD203B41FA5}">
                       <a16:colId xmlns:a16="http://schemas.microsoft.com/office/drawing/2014/main" val="3043373647"/>
                     </a:ext>
                   </a:extLst>
                 </a:gridCol>
-                <a:gridCol w="1419284">
+                <a:gridCol w="1433918">
                   <a:extLst>
                     <a:ext uri="{9D8B030D-6E8A-4147-A177-3AD203B41FA5}">
                       <a16:colId xmlns:a16="http://schemas.microsoft.com/office/drawing/2014/main" val="670270140"/>

</xml_diff>

<commit_message>
Update final project presentation - fixed an error
</commit_message>
<xml_diff>
--- a/Docs/Final_Project_Presentation_Draft.pptx
+++ b/Docs/Final_Project_Presentation_Draft.pptx
@@ -884,40 +884,174 @@
           <a:bodyPr/>
           <a:lstStyle/>
           <a:p>
-            <a:r>
-              <a:rPr lang="en-US" dirty="0"/>
-              <a:t> Our results did not follow the smooth chronological improvements that we’d initially expected.  What we found that was model fit mattered much more than model age.  Hyperparameter tuning and architectural complexity only produced minor improvements when the model was still only learning from the ESC-50 dataset.  Instead, the larger gains were seen when the model was able to use prior knowledge from audio pre-training. </a:t>
-            </a:r>
+            <a:pPr rtl="0">
+              <a:spcBef>
+                <a:spcPts val="1200"/>
+              </a:spcBef>
+              <a:spcAft>
+                <a:spcPts val="1200"/>
+              </a:spcAft>
+              <a:buNone/>
+            </a:pPr>
+            <a:r>
+              <a:rPr lang="en-US" sz="1800" b="0" i="0" u="none" strike="noStrike" dirty="0">
+                <a:solidFill>
+                  <a:srgbClr val="000000"/>
+                </a:solidFill>
+                <a:effectLst/>
+                <a:latin typeface="Arial" panose="020B0604020202020204" pitchFamily="34" charset="0"/>
+              </a:rPr>
+              <a:t>Our results did not show the smooth chronological improvement we initially expected. Instead, the central lesson was that model fit mattered more than model age</a:t>
+            </a:r>
+            <a:endParaRPr lang="en-US" dirty="0">
+              <a:effectLst/>
+            </a:endParaRPr>
+          </a:p>
+          <a:p>
+            <a:pPr rtl="0">
+              <a:spcBef>
+                <a:spcPts val="1200"/>
+              </a:spcBef>
+              <a:spcAft>
+                <a:spcPts val="1200"/>
+              </a:spcAft>
+              <a:buNone/>
+            </a:pPr>
+            <a:r>
+              <a:rPr lang="en-US" sz="1800" b="0" i="0" u="none" strike="noStrike" dirty="0">
+                <a:solidFill>
+                  <a:srgbClr val="000000"/>
+                </a:solidFill>
+                <a:effectLst/>
+                <a:latin typeface="Arial" panose="020B0604020202020204" pitchFamily="34" charset="0"/>
+              </a:rPr>
+              <a:t>CNNs were a strong baseline because spectrogram audio naturally aligns with convolutional feature learning.</a:t>
+            </a:r>
+            <a:endParaRPr lang="en-US" dirty="0">
+              <a:effectLst/>
+            </a:endParaRPr>
+          </a:p>
+          <a:p>
+            <a:pPr rtl="0">
+              <a:spcBef>
+                <a:spcPts val="1200"/>
+              </a:spcBef>
+              <a:spcAft>
+                <a:spcPts val="1200"/>
+              </a:spcAft>
+              <a:buNone/>
+            </a:pPr>
+            <a:r>
+              <a:rPr lang="en-US" sz="1800" b="0" i="0" u="none" strike="noStrike" dirty="0">
+                <a:solidFill>
+                  <a:srgbClr val="000000"/>
+                </a:solidFill>
+                <a:effectLst/>
+                <a:latin typeface="Arial" panose="020B0604020202020204" pitchFamily="34" charset="0"/>
+              </a:rPr>
+              <a:t>Hyperparameter tuning and added architecture complexity helped only a small amount when the model still had to learn from ESC-50 alone, the results aligning to the importance of model selection when also looking at the impacts of the LSTM.</a:t>
+            </a:r>
+            <a:endParaRPr lang="en-US" dirty="0">
+              <a:effectLst/>
+            </a:endParaRPr>
+          </a:p>
+          <a:p>
+            <a:pPr rtl="0">
+              <a:spcBef>
+                <a:spcPts val="1200"/>
+              </a:spcBef>
+              <a:spcAft>
+                <a:spcPts val="1200"/>
+              </a:spcAft>
+              <a:buNone/>
+            </a:pPr>
+            <a:r>
+              <a:rPr lang="en-US" sz="1800" b="0" i="0" u="none" strike="noStrike" dirty="0">
+                <a:solidFill>
+                  <a:srgbClr val="000000"/>
+                </a:solidFill>
+                <a:effectLst/>
+                <a:latin typeface="Arial" panose="020B0604020202020204" pitchFamily="34" charset="0"/>
+              </a:rPr>
+              <a:t>The major gains appeared when the model brought in prior audio knowledge from large-scale pretraining.</a:t>
+            </a:r>
+            <a:endParaRPr lang="en-US" dirty="0">
+              <a:effectLst/>
+            </a:endParaRPr>
+          </a:p>
+          <a:p>
+            <a:pPr rtl="0">
+              <a:spcBef>
+                <a:spcPts val="1200"/>
+              </a:spcBef>
+              <a:spcAft>
+                <a:spcPts val="1200"/>
+              </a:spcAft>
+              <a:buNone/>
+            </a:pPr>
             <a:br>
               <a:rPr lang="en-US" dirty="0"/>
             </a:br>
-            <a:br>
-              <a:rPr lang="en-US" dirty="0"/>
-            </a:br>
-            <a:r>
-              <a:rPr lang="en-US" dirty="0"/>
-              <a:t>As for our lessons learned, we found that our original assumption regarding the data set was accurate – it provided a great benchmark and was able to efficiently be used by various models to help test our hypothesis.  </a:t>
-            </a:r>
-            <a:br>
-              <a:rPr lang="en-US" dirty="0"/>
-            </a:br>
-            <a:br>
-              <a:rPr lang="en-US" dirty="0"/>
-            </a:br>
-            <a:r>
-              <a:rPr lang="en-US" dirty="0"/>
-              <a:t>What we found didn’t go as well is that recreation of the baseline was somewhat of a challenge due to the age of the original test and technological progressions since then.  Additionally, as is often the case with group work, communication and documentation is crucial.  It took a few last second code updates and model re-runs to make sure we had consistent results to compare.  </a:t>
-            </a:r>
-            <a:br>
-              <a:rPr lang="en-US" dirty="0"/>
-            </a:br>
-            <a:br>
-              <a:rPr lang="en-US" dirty="0"/>
-            </a:br>
-            <a:r>
-              <a:rPr lang="en-US" dirty="0"/>
-              <a:t>And lastly, a few things that could be changed to improve the results – it might have helped to use less variants but dive deeper into the results of them, giving us more time to explore the nuances of the models themselves.  Locking in the evaluation protocols would save time going forward.  Introducing a random forest analysis could have provided a more classical baseline to compare to in addition to the neural networks.  And one we had hoped to include but considered a bit too late was the introduction of a runtime metric as measure of improvement rather than just relying on model accuracy.  </a:t>
-            </a:r>
+            <a:r>
+              <a:rPr lang="en-US" sz="1800" b="0" i="0" u="none" strike="noStrike" dirty="0">
+                <a:solidFill>
+                  <a:srgbClr val="000000"/>
+                </a:solidFill>
+                <a:effectLst/>
+                <a:latin typeface="Arial" panose="020B0604020202020204" pitchFamily="34" charset="0"/>
+              </a:rPr>
+              <a:t>What went well was the dataset choice: ESC-50 gave us a compact, clean, repeatable benchmark.</a:t>
+            </a:r>
+            <a:endParaRPr lang="en-US" dirty="0">
+              <a:effectLst/>
+            </a:endParaRPr>
+          </a:p>
+          <a:p>
+            <a:pPr rtl="0">
+              <a:spcBef>
+                <a:spcPts val="1200"/>
+              </a:spcBef>
+              <a:spcAft>
+                <a:spcPts val="1200"/>
+              </a:spcAft>
+              <a:buNone/>
+            </a:pPr>
+            <a:r>
+              <a:rPr lang="en-US" sz="1800" b="0" i="0" u="none" strike="noStrike" dirty="0">
+                <a:solidFill>
+                  <a:srgbClr val="000000"/>
+                </a:solidFill>
+                <a:effectLst/>
+                <a:latin typeface="Arial" panose="020B0604020202020204" pitchFamily="34" charset="0"/>
+              </a:rPr>
+              <a:t>What did not go well was reproducibility and comparison discipline. A 2015 baseline was harder to recreate than expected, and small choices like voting, folds, and final-versus-best accuracy changed the story.</a:t>
+            </a:r>
+            <a:endParaRPr lang="en-US" dirty="0">
+              <a:effectLst/>
+            </a:endParaRPr>
+          </a:p>
+          <a:p>
+            <a:pPr rtl="0">
+              <a:spcBef>
+                <a:spcPts val="1200"/>
+              </a:spcBef>
+              <a:spcAft>
+                <a:spcPts val="1200"/>
+              </a:spcAft>
+            </a:pPr>
+            <a:r>
+              <a:rPr lang="en-US" sz="1800" b="0" i="0" u="none" strike="noStrike" dirty="0">
+                <a:solidFill>
+                  <a:srgbClr val="000000"/>
+                </a:solidFill>
+                <a:effectLst/>
+                <a:latin typeface="Arial" panose="020B0604020202020204" pitchFamily="34" charset="0"/>
+              </a:rPr>
+              <a:t>If we repeated this project, we would lock the evaluation protocol earlier, run fewer variants more deeply, include a classical non-neural baseline, and add runtime or cost as a second performance dimension.</a:t>
+            </a:r>
+            <a:endParaRPr lang="en-US" dirty="0">
+              <a:effectLst/>
+            </a:endParaRPr>
           </a:p>
         </p:txBody>
       </p:sp>
@@ -1001,6 +1135,7 @@
           <a:bodyPr/>
           <a:lstStyle/>
           <a:p>
+            <a:pPr lvl="1"/>
             <a:r>
               <a:rPr lang="en-US" b="0" i="0" dirty="0">
                 <a:solidFill>
@@ -1316,7 +1451,7 @@
             </a:r>
             <a:r>
               <a:rPr lang="en-US" dirty="0"/>
-              <a:t> ESC-50 because we felt his work took a relatively unstudied segment, which was audio sound training, and that would do well to represent the growth in neural network capabilities from that point.  He also had a robust yet compact data set that was well organized – 2000 audio samples, 50 classes, 5 folds – and they were of a manageable size at 5 seconds. Per clip.</a:t>
+              <a:t> ESC-50 because we felt his work took a relatively unstudied segment, which was audio sound training, and that would do well to represent the growth in neural network capabilities from that point.  He also had a robust yet compact data set that was well organized – 2000 audio samples, 50 classes, 5 folds – and they were of a manageable size at 5 seconds per clip, which presented manageable data set to run our multiple different models against.</a:t>
             </a:r>
             <a:br>
               <a:rPr lang="en-US" dirty="0"/>
@@ -1426,6 +1561,89 @@
         <p:txBody>
           <a:bodyPr/>
           <a:lstStyle/>
+          <a:p>
+            <a:pPr rtl="0">
+              <a:buNone/>
+            </a:pPr>
+            <a:r>
+              <a:rPr lang="en-US" sz="1800" b="0" i="0" u="none" strike="noStrike" dirty="0">
+                <a:solidFill>
+                  <a:srgbClr val="000000"/>
+                </a:solidFill>
+                <a:effectLst/>
+                <a:latin typeface="Arial" panose="020B0604020202020204" pitchFamily="34" charset="0"/>
+              </a:rPr>
+              <a:t>In this block we are looking at neural network models that rely solely on the data set for training. That means it has to first learn the features of the audio clips themselves, the acoustic patterns in the </a:t>
+            </a:r>
+            <a:r>
+              <a:rPr lang="en-US" sz="1800" b="0" i="0" u="none" strike="noStrike" dirty="0" err="1">
+                <a:solidFill>
+                  <a:srgbClr val="000000"/>
+                </a:solidFill>
+                <a:effectLst/>
+                <a:latin typeface="Arial" panose="020B0604020202020204" pitchFamily="34" charset="0"/>
+              </a:rPr>
+              <a:t>spectogram</a:t>
+            </a:r>
+            <a:r>
+              <a:rPr lang="en-US" sz="1800" b="0" i="0" u="none" strike="noStrike" dirty="0">
+                <a:solidFill>
+                  <a:srgbClr val="000000"/>
+                </a:solidFill>
+                <a:effectLst/>
+                <a:latin typeface="Arial" panose="020B0604020202020204" pitchFamily="34" charset="0"/>
+              </a:rPr>
+              <a:t> that would help distinguish classes - short bursts of sound like a dog bark, repetitive textures like a bird chirp, or changes over time.  Then it has to learn the classifier, meaning mapping those patterns to the labels from ESC-50.</a:t>
+            </a:r>
+            <a:endParaRPr lang="en-US" dirty="0">
+              <a:effectLst/>
+            </a:endParaRPr>
+          </a:p>
+          <a:p>
+            <a:pPr rtl="0"/>
+            <a:br>
+              <a:rPr lang="en-US" sz="1800" b="0" i="0" u="none" strike="noStrike" dirty="0">
+                <a:solidFill>
+                  <a:srgbClr val="000000"/>
+                </a:solidFill>
+                <a:effectLst/>
+                <a:latin typeface="Arial" panose="020B0604020202020204" pitchFamily="34" charset="0"/>
+              </a:rPr>
+            </a:br>
+            <a:r>
+              <a:rPr lang="en-US" sz="1800" b="0" i="0" u="none" strike="noStrike" dirty="0">
+                <a:solidFill>
+                  <a:srgbClr val="000000"/>
+                </a:solidFill>
+                <a:effectLst/>
+                <a:latin typeface="Arial" panose="020B0604020202020204" pitchFamily="34" charset="0"/>
+              </a:rPr>
+              <a:t>Here we look at first recreating </a:t>
+            </a:r>
+            <a:r>
+              <a:rPr lang="en-US" sz="1800" b="0" i="0" u="none" strike="noStrike" dirty="0" err="1">
+                <a:solidFill>
+                  <a:srgbClr val="000000"/>
+                </a:solidFill>
+                <a:effectLst/>
+                <a:latin typeface="Arial" panose="020B0604020202020204" pitchFamily="34" charset="0"/>
+              </a:rPr>
+              <a:t>Piczak’s</a:t>
+            </a:r>
+            <a:r>
+              <a:rPr lang="en-US" sz="1800" b="0" i="0" u="none" strike="noStrike" dirty="0">
+                <a:solidFill>
+                  <a:srgbClr val="000000"/>
+                </a:solidFill>
+                <a:effectLst/>
+                <a:latin typeface="Arial" panose="020B0604020202020204" pitchFamily="34" charset="0"/>
+              </a:rPr>
+              <a:t> model to build our baseline, then we run a series of CNN variations before introducing an LSTM extension.</a:t>
+            </a:r>
+            <a:endParaRPr lang="en-US" dirty="0">
+              <a:effectLst/>
+            </a:endParaRPr>
+          </a:p>
           <a:p>
             <a:endParaRPr lang="en-US" dirty="0"/>
           </a:p>
@@ -12108,9 +12326,9 @@
         <p:grpSpPr>
           <a:xfrm>
             <a:off x="6076188" y="4092809"/>
-            <a:ext cx="2011680" cy="772294"/>
+            <a:ext cx="1920240" cy="772294"/>
             <a:chOff x="6957490" y="4123666"/>
-            <a:chExt cx="2011680" cy="772294"/>
+            <a:chExt cx="1920240" cy="772294"/>
           </a:xfrm>
         </p:grpSpPr>
         <p:sp>
@@ -12128,7 +12346,7 @@
           <p:spPr>
             <a:xfrm>
               <a:off x="6957490" y="4123666"/>
-              <a:ext cx="2011680" cy="772294"/>
+              <a:ext cx="1920012" cy="772294"/>
             </a:xfrm>
             <a:prstGeom prst="rect">
               <a:avLst/>
@@ -12300,6 +12518,66 @@
           <a:chExt cx="0" cy="0"/>
         </a:xfrm>
       </p:grpSpPr>
+      <p:pic>
+        <p:nvPicPr>
+          <p:cNvPr id="5" name="Picture 4">
+            <a:extLst>
+              <a:ext uri="{FF2B5EF4-FFF2-40B4-BE49-F238E27FC236}">
+                <a16:creationId xmlns:a16="http://schemas.microsoft.com/office/drawing/2014/main" id="{4118E2C7-E5C7-CD2E-AEBD-8960927E5AF3}"/>
+              </a:ext>
+            </a:extLst>
+          </p:cNvPr>
+          <p:cNvPicPr>
+            <a:picLocks noChangeAspect="1"/>
+          </p:cNvPicPr>
+          <p:nvPr/>
+        </p:nvPicPr>
+        <p:blipFill>
+          <a:blip r:embed="rId3"/>
+          <a:stretch>
+            <a:fillRect/>
+          </a:stretch>
+        </p:blipFill>
+        <p:spPr>
+          <a:xfrm>
+            <a:off x="5592822" y="1885417"/>
+            <a:ext cx="3216083" cy="1988679"/>
+          </a:xfrm>
+          <a:prstGeom prst="rect">
+            <a:avLst/>
+          </a:prstGeom>
+        </p:spPr>
+      </p:pic>
+      <p:pic>
+        <p:nvPicPr>
+          <p:cNvPr id="6" name="Picture 5">
+            <a:extLst>
+              <a:ext uri="{FF2B5EF4-FFF2-40B4-BE49-F238E27FC236}">
+                <a16:creationId xmlns:a16="http://schemas.microsoft.com/office/drawing/2014/main" id="{D5C5E91D-FE7B-206B-2E5B-5ED91A81AD94}"/>
+              </a:ext>
+            </a:extLst>
+          </p:cNvPr>
+          <p:cNvPicPr>
+            <a:picLocks noChangeAspect="1"/>
+          </p:cNvPicPr>
+          <p:nvPr/>
+        </p:nvPicPr>
+        <p:blipFill>
+          <a:blip r:embed="rId4"/>
+          <a:stretch>
+            <a:fillRect/>
+          </a:stretch>
+        </p:blipFill>
+        <p:spPr>
+          <a:xfrm>
+            <a:off x="8808906" y="1885417"/>
+            <a:ext cx="3249450" cy="1988679"/>
+          </a:xfrm>
+          <a:prstGeom prst="rect">
+            <a:avLst/>
+          </a:prstGeom>
+        </p:spPr>
+      </p:pic>
       <p:sp>
         <p:nvSpPr>
           <p:cNvPr id="2" name="Text 0"/>
@@ -12459,128 +12737,6 @@
               <a:t>12</a:t>
             </a:r>
             <a:endParaRPr lang="en-US" sz="750" dirty="0"/>
-          </a:p>
-        </p:txBody>
-      </p:sp>
-      <p:sp>
-        <p:nvSpPr>
-          <p:cNvPr id="32" name="Shape 30"/>
-          <p:cNvSpPr/>
-          <p:nvPr/>
-        </p:nvSpPr>
-        <p:spPr>
-          <a:xfrm>
-            <a:off x="9078898" y="4125942"/>
-            <a:ext cx="2011680" cy="770018"/>
-          </a:xfrm>
-          <a:prstGeom prst="rect">
-            <a:avLst/>
-          </a:prstGeom>
-          <a:solidFill>
-            <a:srgbClr val="FFFFFF">
-              <a:alpha val="98000"/>
-            </a:srgbClr>
-          </a:solidFill>
-          <a:ln w="17780">
-            <a:solidFill>
-              <a:srgbClr val="B65D3A"/>
-            </a:solidFill>
-            <a:prstDash val="solid"/>
-          </a:ln>
-        </p:spPr>
-        <p:txBody>
-          <a:bodyPr/>
-          <a:lstStyle/>
-          <a:p>
-            <a:endParaRPr lang="en-US"/>
-          </a:p>
-        </p:txBody>
-      </p:sp>
-      <p:sp>
-        <p:nvSpPr>
-          <p:cNvPr id="33" name="Text 31"/>
-          <p:cNvSpPr/>
-          <p:nvPr/>
-        </p:nvSpPr>
-        <p:spPr>
-          <a:xfrm>
-            <a:off x="9078898" y="4263102"/>
-            <a:ext cx="2011680" cy="329184"/>
-          </a:xfrm>
-          <a:prstGeom prst="rect">
-            <a:avLst/>
-          </a:prstGeom>
-          <a:noFill/>
-          <a:ln/>
-        </p:spPr>
-        <p:txBody>
-          <a:bodyPr wrap="square" lIns="0" tIns="0" rIns="0" bIns="0" rtlCol="0" anchor="t">
-            <a:normAutofit/>
-          </a:bodyPr>
-          <a:lstStyle/>
-          <a:p>
-            <a:pPr marL="0" indent="0" algn="ctr">
-              <a:lnSpc>
-                <a:spcPct val="90000"/>
-              </a:lnSpc>
-              <a:buNone/>
-            </a:pPr>
-            <a:r>
-              <a:rPr lang="en-US" sz="2100" b="1" dirty="0">
-                <a:solidFill>
-                  <a:srgbClr val="B65D3A"/>
-                </a:solidFill>
-                <a:latin typeface="Aptos Display" pitchFamily="34" charset="0"/>
-                <a:ea typeface="Aptos Display" pitchFamily="34" charset="-122"/>
-                <a:cs typeface="Aptos Display" pitchFamily="34" charset="-120"/>
-              </a:rPr>
-              <a:t>94.40%</a:t>
-            </a:r>
-            <a:endParaRPr lang="en-US" sz="2100" dirty="0"/>
-          </a:p>
-        </p:txBody>
-      </p:sp>
-      <p:sp>
-        <p:nvSpPr>
-          <p:cNvPr id="34" name="Text 32"/>
-          <p:cNvSpPr/>
-          <p:nvPr/>
-        </p:nvSpPr>
-        <p:spPr>
-          <a:xfrm>
-            <a:off x="9078898" y="4656294"/>
-            <a:ext cx="2011680" cy="219456"/>
-          </a:xfrm>
-          <a:prstGeom prst="rect">
-            <a:avLst/>
-          </a:prstGeom>
-          <a:noFill/>
-          <a:ln/>
-        </p:spPr>
-        <p:txBody>
-          <a:bodyPr wrap="square" lIns="0" tIns="0" rIns="0" bIns="0" rtlCol="0" anchor="t">
-            <a:normAutofit/>
-          </a:bodyPr>
-          <a:lstStyle/>
-          <a:p>
-            <a:pPr marL="0" indent="0" algn="ctr">
-              <a:lnSpc>
-                <a:spcPct val="90000"/>
-              </a:lnSpc>
-              <a:buNone/>
-            </a:pPr>
-            <a:r>
-              <a:rPr lang="en-US" sz="780" dirty="0">
-                <a:solidFill>
-                  <a:srgbClr val="6B7176"/>
-                </a:solidFill>
-                <a:latin typeface="Aptos" pitchFamily="34" charset="0"/>
-                <a:ea typeface="Aptos" pitchFamily="34" charset="-122"/>
-                <a:cs typeface="Aptos" pitchFamily="34" charset="-120"/>
-              </a:rPr>
-              <a:t>final 5-fold accuracy</a:t>
-            </a:r>
-            <a:endParaRPr lang="en-US" sz="780" dirty="0"/>
           </a:p>
         </p:txBody>
       </p:sp>
@@ -12643,7 +12799,7 @@
           <p:nvPr/>
         </p:nvPicPr>
         <p:blipFill rotWithShape="1">
-          <a:blip r:embed="rId3">
+          <a:blip r:embed="rId5">
             <a:extLst>
               <a:ext uri="{28A0092B-C50C-407E-A947-70E740481C1C}">
                 <a14:useLocalDpi xmlns:a14="http://schemas.microsoft.com/office/drawing/2010/main" val="0"/>
@@ -14550,12 +14706,152 @@
           </a:p>
         </p:txBody>
       </p:sp>
+      <p:sp>
+        <p:nvSpPr>
+          <p:cNvPr id="23" name="Shape 498">
+            <a:extLst>
+              <a:ext uri="{FF2B5EF4-FFF2-40B4-BE49-F238E27FC236}">
+                <a16:creationId xmlns:a16="http://schemas.microsoft.com/office/drawing/2014/main" id="{D9FC713D-E54E-5DD4-5B73-CA6AC57E7A9E}"/>
+              </a:ext>
+            </a:extLst>
+          </p:cNvPr>
+          <p:cNvSpPr/>
+          <p:nvPr/>
+        </p:nvSpPr>
+        <p:spPr>
+          <a:xfrm>
+            <a:off x="8239330" y="4084421"/>
+            <a:ext cx="1920012" cy="780682"/>
+          </a:xfrm>
+          <a:prstGeom prst="rect">
+            <a:avLst/>
+          </a:prstGeom>
+          <a:solidFill>
+            <a:srgbClr val="FFFFFF">
+              <a:alpha val="98000"/>
+            </a:srgbClr>
+          </a:solidFill>
+          <a:ln w="17780">
+            <a:solidFill>
+              <a:srgbClr val="B65D3A"/>
+            </a:solidFill>
+            <a:prstDash val="solid"/>
+          </a:ln>
+        </p:spPr>
+        <p:txBody>
+          <a:bodyPr/>
+          <a:lstStyle/>
+          <a:p>
+            <a:endParaRPr lang="en-US"/>
+          </a:p>
+        </p:txBody>
+      </p:sp>
+      <p:sp>
+        <p:nvSpPr>
+          <p:cNvPr id="24" name="Text 499">
+            <a:extLst>
+              <a:ext uri="{FF2B5EF4-FFF2-40B4-BE49-F238E27FC236}">
+                <a16:creationId xmlns:a16="http://schemas.microsoft.com/office/drawing/2014/main" id="{4362304F-343B-923E-3087-86ABABE95DDD}"/>
+              </a:ext>
+            </a:extLst>
+          </p:cNvPr>
+          <p:cNvSpPr/>
+          <p:nvPr/>
+        </p:nvSpPr>
+        <p:spPr>
+          <a:xfrm>
+            <a:off x="8239330" y="4224527"/>
+            <a:ext cx="1920012" cy="329184"/>
+          </a:xfrm>
+          <a:prstGeom prst="rect">
+            <a:avLst/>
+          </a:prstGeom>
+          <a:noFill/>
+          <a:ln/>
+        </p:spPr>
+        <p:txBody>
+          <a:bodyPr wrap="square" lIns="0" tIns="0" rIns="0" bIns="0" rtlCol="0" anchor="t">
+            <a:normAutofit/>
+          </a:bodyPr>
+          <a:lstStyle/>
+          <a:p>
+            <a:pPr marL="0" indent="0" algn="ctr">
+              <a:lnSpc>
+                <a:spcPct val="90000"/>
+              </a:lnSpc>
+              <a:buNone/>
+            </a:pPr>
+            <a:r>
+              <a:rPr lang="en-US" sz="2100" b="1" dirty="0">
+                <a:solidFill>
+                  <a:srgbClr val="B65D3A"/>
+                </a:solidFill>
+                <a:latin typeface="Aptos Display" pitchFamily="34" charset="0"/>
+                <a:ea typeface="Aptos Display" pitchFamily="34" charset="-122"/>
+                <a:cs typeface="Aptos Display" pitchFamily="34" charset="-120"/>
+              </a:rPr>
+              <a:t>94.4%</a:t>
+            </a:r>
+            <a:endParaRPr lang="en-US" sz="2100" dirty="0"/>
+          </a:p>
+        </p:txBody>
+      </p:sp>
+      <p:sp>
+        <p:nvSpPr>
+          <p:cNvPr id="25" name="Text 500">
+            <a:extLst>
+              <a:ext uri="{FF2B5EF4-FFF2-40B4-BE49-F238E27FC236}">
+                <a16:creationId xmlns:a16="http://schemas.microsoft.com/office/drawing/2014/main" id="{ED633736-DC22-5ED4-B73D-FDA8289C8F79}"/>
+              </a:ext>
+            </a:extLst>
+          </p:cNvPr>
+          <p:cNvSpPr/>
+          <p:nvPr/>
+        </p:nvSpPr>
+        <p:spPr>
+          <a:xfrm>
+            <a:off x="8239330" y="4617719"/>
+            <a:ext cx="1920012" cy="219456"/>
+          </a:xfrm>
+          <a:prstGeom prst="rect">
+            <a:avLst/>
+          </a:prstGeom>
+          <a:noFill/>
+          <a:ln/>
+        </p:spPr>
+        <p:txBody>
+          <a:bodyPr wrap="square" lIns="0" tIns="0" rIns="0" bIns="0" rtlCol="0" anchor="t">
+            <a:normAutofit/>
+          </a:bodyPr>
+          <a:lstStyle/>
+          <a:p>
+            <a:pPr marL="0" indent="0" algn="ctr">
+              <a:lnSpc>
+                <a:spcPct val="90000"/>
+              </a:lnSpc>
+              <a:buNone/>
+            </a:pPr>
+            <a:r>
+              <a:rPr lang="en-US" sz="780" dirty="0">
+                <a:solidFill>
+                  <a:srgbClr val="6B7176"/>
+                </a:solidFill>
+                <a:latin typeface="Aptos" pitchFamily="34" charset="0"/>
+                <a:ea typeface="Aptos" pitchFamily="34" charset="-122"/>
+                <a:cs typeface="Aptos" pitchFamily="34" charset="-120"/>
+              </a:rPr>
+              <a:t>final 5-fold accuracy</a:t>
+            </a:r>
+            <a:endParaRPr lang="en-US" sz="780" dirty="0"/>
+          </a:p>
+        </p:txBody>
+      </p:sp>
       <p:grpSp>
         <p:nvGrpSpPr>
-          <p:cNvPr id="5" name="Group 4">
+          <p:cNvPr id="26" name="Group 25">
             <a:extLst>
               <a:ext uri="{FF2B5EF4-FFF2-40B4-BE49-F238E27FC236}">
-                <a16:creationId xmlns:a16="http://schemas.microsoft.com/office/drawing/2014/main" id="{BE88CA5D-B2F9-1E52-6AC1-F2B64A98F10B}"/>
+                <a16:creationId xmlns:a16="http://schemas.microsoft.com/office/drawing/2014/main" id="{B18A83C6-62D2-E441-C96A-51AEEA5D47AC}"/>
               </a:ext>
             </a:extLst>
           </p:cNvPr>
@@ -14564,18 +14860,18 @@
         </p:nvGrpSpPr>
         <p:grpSpPr>
           <a:xfrm>
-            <a:off x="6957490" y="4123666"/>
-            <a:ext cx="2011680" cy="772294"/>
+            <a:off x="6076188" y="4092809"/>
+            <a:ext cx="1920240" cy="772294"/>
             <a:chOff x="6957490" y="4123666"/>
-            <a:chExt cx="2011680" cy="772294"/>
+            <a:chExt cx="1920240" cy="772294"/>
           </a:xfrm>
         </p:grpSpPr>
         <p:sp>
           <p:nvSpPr>
-            <p:cNvPr id="6" name="Shape 48">
+            <p:cNvPr id="27" name="Shape 48">
               <a:extLst>
                 <a:ext uri="{FF2B5EF4-FFF2-40B4-BE49-F238E27FC236}">
-                  <a16:creationId xmlns:a16="http://schemas.microsoft.com/office/drawing/2014/main" id="{7C39D036-9001-3BE9-8E12-1F1E84C39011}"/>
+                  <a16:creationId xmlns:a16="http://schemas.microsoft.com/office/drawing/2014/main" id="{2FBA8E6F-4D3F-F840-786D-0EABE6DB37C4}"/>
                 </a:ext>
               </a:extLst>
             </p:cNvPr>
@@ -14585,7 +14881,7 @@
           <p:spPr>
             <a:xfrm>
               <a:off x="6957490" y="4123666"/>
-              <a:ext cx="2011680" cy="772294"/>
+              <a:ext cx="1920012" cy="772294"/>
             </a:xfrm>
             <a:prstGeom prst="rect">
               <a:avLst/>
@@ -14615,10 +14911,10 @@
         </p:sp>
         <p:sp>
           <p:nvSpPr>
-            <p:cNvPr id="7" name="Text 49">
+            <p:cNvPr id="28" name="Text 49">
               <a:extLst>
                 <a:ext uri="{FF2B5EF4-FFF2-40B4-BE49-F238E27FC236}">
-                  <a16:creationId xmlns:a16="http://schemas.microsoft.com/office/drawing/2014/main" id="{EB63FAAC-CA55-8265-32E9-E0A1E7CBFF12}"/>
+                  <a16:creationId xmlns:a16="http://schemas.microsoft.com/office/drawing/2014/main" id="{A8DB9481-E320-7256-6DA0-124012C48D24}"/>
                 </a:ext>
               </a:extLst>
             </p:cNvPr>
@@ -14675,10 +14971,10 @@
         </p:sp>
         <p:sp>
           <p:nvSpPr>
-            <p:cNvPr id="8" name="Text 50">
+            <p:cNvPr id="29" name="Text 50">
               <a:extLst>
                 <a:ext uri="{FF2B5EF4-FFF2-40B4-BE49-F238E27FC236}">
-                  <a16:creationId xmlns:a16="http://schemas.microsoft.com/office/drawing/2014/main" id="{6E135FD5-F32A-7220-4260-D615BBDE8940}"/>
+                  <a16:creationId xmlns:a16="http://schemas.microsoft.com/office/drawing/2014/main" id="{9B484ADC-A341-3E48-D371-6B3027AD37A4}"/>
                 </a:ext>
               </a:extLst>
             </p:cNvPr>
@@ -14724,66 +15020,6 @@
           </p:txBody>
         </p:sp>
       </p:grpSp>
-      <p:pic>
-        <p:nvPicPr>
-          <p:cNvPr id="9" name="Picture 8">
-            <a:extLst>
-              <a:ext uri="{FF2B5EF4-FFF2-40B4-BE49-F238E27FC236}">
-                <a16:creationId xmlns:a16="http://schemas.microsoft.com/office/drawing/2014/main" id="{ED6FB033-FAE8-90C0-9FC0-83AC1D7A59C7}"/>
-              </a:ext>
-            </a:extLst>
-          </p:cNvPr>
-          <p:cNvPicPr>
-            <a:picLocks noChangeAspect="1"/>
-          </p:cNvPicPr>
-          <p:nvPr/>
-        </p:nvPicPr>
-        <p:blipFill>
-          <a:blip r:embed="rId4"/>
-          <a:stretch>
-            <a:fillRect/>
-          </a:stretch>
-        </p:blipFill>
-        <p:spPr>
-          <a:xfrm>
-            <a:off x="5859811" y="2022666"/>
-            <a:ext cx="3109359" cy="1922686"/>
-          </a:xfrm>
-          <a:prstGeom prst="rect">
-            <a:avLst/>
-          </a:prstGeom>
-        </p:spPr>
-      </p:pic>
-      <p:pic>
-        <p:nvPicPr>
-          <p:cNvPr id="10" name="Picture 9">
-            <a:extLst>
-              <a:ext uri="{FF2B5EF4-FFF2-40B4-BE49-F238E27FC236}">
-                <a16:creationId xmlns:a16="http://schemas.microsoft.com/office/drawing/2014/main" id="{F77EEF88-F60B-56A1-4677-329A753740B8}"/>
-              </a:ext>
-            </a:extLst>
-          </p:cNvPr>
-          <p:cNvPicPr>
-            <a:picLocks noChangeAspect="1"/>
-          </p:cNvPicPr>
-          <p:nvPr/>
-        </p:nvPicPr>
-        <p:blipFill>
-          <a:blip r:embed="rId5"/>
-          <a:stretch>
-            <a:fillRect/>
-          </a:stretch>
-        </p:blipFill>
-        <p:spPr>
-          <a:xfrm>
-            <a:off x="8969170" y="2033018"/>
-            <a:ext cx="3109359" cy="1922686"/>
-          </a:xfrm>
-          <a:prstGeom prst="rect">
-            <a:avLst/>
-          </a:prstGeom>
-        </p:spPr>
-      </p:pic>
     </p:spTree>
   </p:cSld>
   <p:clrMapOvr>
@@ -14899,8 +15135,8 @@
         </p:nvSpPr>
         <p:spPr>
           <a:xfrm>
-            <a:off x="731520" y="1261872"/>
-            <a:ext cx="6035040" cy="411480"/>
+            <a:off x="731520" y="1347624"/>
+            <a:ext cx="4922521" cy="411480"/>
           </a:xfrm>
           <a:prstGeom prst="rect">
             <a:avLst/>
@@ -14943,7 +15179,7 @@
         </p:nvSpPr>
         <p:spPr>
           <a:xfrm>
-            <a:off x="731520" y="2110784"/>
+            <a:off x="731520" y="2336071"/>
             <a:ext cx="2468880" cy="164592"/>
           </a:xfrm>
           <a:prstGeom prst="rect">
@@ -14989,7 +15225,7 @@
         </p:nvSpPr>
         <p:spPr>
           <a:xfrm>
-            <a:off x="3337560" y="2211368"/>
+            <a:off x="3337560" y="2436655"/>
             <a:ext cx="2148840" cy="0"/>
           </a:xfrm>
           <a:prstGeom prst="line">
@@ -15019,7 +15255,7 @@
         </p:nvSpPr>
         <p:spPr>
           <a:xfrm>
-            <a:off x="3337560" y="2129072"/>
+            <a:off x="3337560" y="2354359"/>
             <a:ext cx="1386002" cy="155448"/>
           </a:xfrm>
           <a:prstGeom prst="rect">
@@ -15053,7 +15289,7 @@
         </p:nvSpPr>
         <p:spPr>
           <a:xfrm>
-            <a:off x="4815002" y="2110784"/>
+            <a:off x="4815002" y="2336071"/>
             <a:ext cx="658368" cy="146304"/>
           </a:xfrm>
           <a:prstGeom prst="rect">
@@ -15097,7 +15333,7 @@
         </p:nvSpPr>
         <p:spPr>
           <a:xfrm>
-            <a:off x="731520" y="2739990"/>
+            <a:off x="731520" y="2965277"/>
             <a:ext cx="2468880" cy="164592"/>
           </a:xfrm>
           <a:prstGeom prst="rect">
@@ -15141,7 +15377,7 @@
         </p:nvSpPr>
         <p:spPr>
           <a:xfrm>
-            <a:off x="3337560" y="2840574"/>
+            <a:off x="3337560" y="3065861"/>
             <a:ext cx="2148840" cy="0"/>
           </a:xfrm>
           <a:prstGeom prst="line">
@@ -15171,7 +15407,7 @@
         </p:nvSpPr>
         <p:spPr>
           <a:xfrm>
-            <a:off x="3337560" y="2758278"/>
+            <a:off x="3337560" y="2983565"/>
             <a:ext cx="1220541" cy="155448"/>
           </a:xfrm>
           <a:prstGeom prst="rect">
@@ -15205,7 +15441,7 @@
         </p:nvSpPr>
         <p:spPr>
           <a:xfrm>
-            <a:off x="4649541" y="2739990"/>
+            <a:off x="4649541" y="2965277"/>
             <a:ext cx="658368" cy="146304"/>
           </a:xfrm>
           <a:prstGeom prst="rect">
@@ -15249,7 +15485,7 @@
         </p:nvSpPr>
         <p:spPr>
           <a:xfrm>
-            <a:off x="731520" y="3268616"/>
+            <a:off x="731520" y="3493903"/>
             <a:ext cx="2468880" cy="164592"/>
           </a:xfrm>
           <a:prstGeom prst="rect">
@@ -15293,7 +15529,7 @@
         </p:nvSpPr>
         <p:spPr>
           <a:xfrm>
-            <a:off x="3337560" y="3369200"/>
+            <a:off x="3337560" y="3594487"/>
             <a:ext cx="2148840" cy="0"/>
           </a:xfrm>
           <a:prstGeom prst="line">
@@ -15323,7 +15559,7 @@
         </p:nvSpPr>
         <p:spPr>
           <a:xfrm>
-            <a:off x="3337560" y="3286904"/>
+            <a:off x="3337560" y="3512191"/>
             <a:ext cx="1213020" cy="155448"/>
           </a:xfrm>
           <a:prstGeom prst="rect">
@@ -15357,7 +15593,7 @@
         </p:nvSpPr>
         <p:spPr>
           <a:xfrm>
-            <a:off x="4642020" y="3268616"/>
+            <a:off x="4642020" y="3493903"/>
             <a:ext cx="658368" cy="146304"/>
           </a:xfrm>
           <a:prstGeom prst="rect">
@@ -15401,7 +15637,7 @@
         </p:nvSpPr>
         <p:spPr>
           <a:xfrm>
-            <a:off x="731520" y="3588656"/>
+            <a:off x="731520" y="3813943"/>
             <a:ext cx="2468880" cy="164592"/>
           </a:xfrm>
           <a:prstGeom prst="rect">
@@ -15445,7 +15681,7 @@
         </p:nvSpPr>
         <p:spPr>
           <a:xfrm>
-            <a:off x="3337560" y="3689240"/>
+            <a:off x="3337560" y="3914527"/>
             <a:ext cx="2148840" cy="0"/>
           </a:xfrm>
           <a:prstGeom prst="line">
@@ -15475,7 +15711,7 @@
         </p:nvSpPr>
         <p:spPr>
           <a:xfrm>
-            <a:off x="3337560" y="3606944"/>
+            <a:off x="3337560" y="3832231"/>
             <a:ext cx="1792133" cy="155448"/>
           </a:xfrm>
           <a:prstGeom prst="rect">
@@ -15509,7 +15745,7 @@
         </p:nvSpPr>
         <p:spPr>
           <a:xfrm>
-            <a:off x="5221133" y="3588656"/>
+            <a:off x="5221133" y="3813943"/>
             <a:ext cx="658368" cy="146304"/>
           </a:xfrm>
           <a:prstGeom prst="rect">
@@ -15553,7 +15789,7 @@
         </p:nvSpPr>
         <p:spPr>
           <a:xfrm>
-            <a:off x="731520" y="4124696"/>
+            <a:off x="731520" y="4349983"/>
             <a:ext cx="2468880" cy="164592"/>
           </a:xfrm>
           <a:prstGeom prst="rect">
@@ -15597,7 +15833,7 @@
         </p:nvSpPr>
         <p:spPr>
           <a:xfrm>
-            <a:off x="3337560" y="4225280"/>
+            <a:off x="3337560" y="4450567"/>
             <a:ext cx="2148840" cy="0"/>
           </a:xfrm>
           <a:prstGeom prst="line">
@@ -15627,7 +15863,7 @@
         </p:nvSpPr>
         <p:spPr>
           <a:xfrm>
-            <a:off x="3337560" y="4142984"/>
+            <a:off x="3337560" y="4368271"/>
             <a:ext cx="2028505" cy="155448"/>
           </a:xfrm>
           <a:prstGeom prst="rect">
@@ -15661,7 +15897,7 @@
         </p:nvSpPr>
         <p:spPr>
           <a:xfrm>
-            <a:off x="5457505" y="4124696"/>
+            <a:off x="5457505" y="4349983"/>
             <a:ext cx="658368" cy="146304"/>
           </a:xfrm>
           <a:prstGeom prst="rect">
@@ -15705,7 +15941,7 @@
         </p:nvSpPr>
         <p:spPr>
           <a:xfrm>
-            <a:off x="731520" y="4444736"/>
+            <a:off x="731520" y="4670023"/>
             <a:ext cx="2468880" cy="164592"/>
           </a:xfrm>
           <a:prstGeom prst="rect">
@@ -15749,7 +15985,7 @@
         </p:nvSpPr>
         <p:spPr>
           <a:xfrm>
-            <a:off x="3337560" y="4545320"/>
+            <a:off x="3337560" y="4770607"/>
             <a:ext cx="2148840" cy="0"/>
           </a:xfrm>
           <a:prstGeom prst="line">
@@ -15779,7 +16015,7 @@
         </p:nvSpPr>
         <p:spPr>
           <a:xfrm>
-            <a:off x="3337560" y="4463024"/>
+            <a:off x="3337560" y="4688311"/>
             <a:ext cx="2046770" cy="155448"/>
           </a:xfrm>
           <a:prstGeom prst="rect">
@@ -15813,7 +16049,7 @@
         </p:nvSpPr>
         <p:spPr>
           <a:xfrm>
-            <a:off x="5475770" y="4444736"/>
+            <a:off x="5475770" y="4670023"/>
             <a:ext cx="658368" cy="146304"/>
           </a:xfrm>
           <a:prstGeom prst="rect">
@@ -16049,7 +16285,7 @@
         </p:nvSpPr>
         <p:spPr>
           <a:xfrm>
-            <a:off x="6702552" y="3072384"/>
+            <a:off x="6702552" y="2986246"/>
             <a:ext cx="4389120" cy="164592"/>
           </a:xfrm>
           <a:prstGeom prst="rect">
@@ -16382,7 +16618,7 @@
         </p:nvSpPr>
         <p:spPr>
           <a:xfrm>
-            <a:off x="731520" y="2430823"/>
+            <a:off x="731520" y="2656110"/>
             <a:ext cx="2468880" cy="164592"/>
           </a:xfrm>
           <a:prstGeom prst="rect">
@@ -16445,7 +16681,7 @@
         </p:nvSpPr>
         <p:spPr>
           <a:xfrm>
-            <a:off x="3337560" y="2531407"/>
+            <a:off x="3337560" y="2756694"/>
             <a:ext cx="2148840" cy="0"/>
           </a:xfrm>
           <a:prstGeom prst="line">
@@ -16481,7 +16717,7 @@
         </p:nvSpPr>
         <p:spPr>
           <a:xfrm>
-            <a:off x="3337560" y="2449111"/>
+            <a:off x="3337560" y="2674398"/>
             <a:ext cx="1463629" cy="155448"/>
           </a:xfrm>
           <a:prstGeom prst="rect">
@@ -16521,7 +16757,7 @@
         </p:nvSpPr>
         <p:spPr>
           <a:xfrm>
-            <a:off x="4891949" y="2439970"/>
+            <a:off x="4891949" y="2665257"/>
             <a:ext cx="658368" cy="146304"/>
           </a:xfrm>
           <a:prstGeom prst="rect">
@@ -16573,7 +16809,7 @@
         </p:nvCxnSpPr>
         <p:spPr>
           <a:xfrm>
-            <a:off x="1594512" y="3081918"/>
+            <a:off x="1594512" y="3307205"/>
             <a:ext cx="2688538" cy="0"/>
           </a:xfrm>
           <a:prstGeom prst="line">
@@ -16619,7 +16855,7 @@
         </p:nvCxnSpPr>
         <p:spPr>
           <a:xfrm>
-            <a:off x="1530912" y="3945272"/>
+            <a:off x="1530912" y="4170559"/>
             <a:ext cx="2688538" cy="0"/>
           </a:xfrm>
           <a:prstGeom prst="line">
@@ -21672,14 +21908,16 @@
         </p:nvSpPr>
         <p:spPr>
           <a:xfrm>
-            <a:off x="743871" y="2377918"/>
+            <a:off x="731520" y="2377916"/>
             <a:ext cx="2926080" cy="182880"/>
           </a:xfrm>
           <a:prstGeom prst="rect">
             <a:avLst/>
           </a:prstGeom>
           <a:noFill/>
-          <a:ln/>
+          <a:ln>
+            <a:noFill/>
+          </a:ln>
         </p:spPr>
         <p:txBody>
           <a:bodyPr wrap="square" lIns="0" tIns="0" rIns="0" bIns="0" rtlCol="0" anchor="t">
@@ -21967,61 +22205,6 @@
               <a:t>Baseline Replication</a:t>
             </a:r>
             <a:endParaRPr lang="en-US" sz="780" dirty="0"/>
-          </a:p>
-        </p:txBody>
-      </p:sp>
-      <p:sp>
-        <p:nvSpPr>
-          <p:cNvPr id="56" name="Text 54"/>
-          <p:cNvSpPr/>
-          <p:nvPr/>
-        </p:nvSpPr>
-        <p:spPr>
-          <a:xfrm>
-            <a:off x="6957490" y="5129506"/>
-            <a:ext cx="4389120" cy="274320"/>
-          </a:xfrm>
-          <a:prstGeom prst="rect">
-            <a:avLst/>
-          </a:prstGeom>
-          <a:noFill/>
-          <a:ln/>
-        </p:spPr>
-        <p:txBody>
-          <a:bodyPr wrap="square" lIns="0" tIns="0" rIns="0" bIns="0" rtlCol="0" anchor="t">
-            <a:normAutofit/>
-          </a:bodyPr>
-          <a:lstStyle/>
-          <a:p>
-            <a:pPr marL="0" indent="0" algn="l">
-              <a:lnSpc>
-                <a:spcPct val="82000"/>
-              </a:lnSpc>
-              <a:buNone/>
-            </a:pPr>
-            <a:r>
-              <a:rPr lang="en-US" sz="850" i="1" dirty="0">
-                <a:solidFill>
-                  <a:srgbClr val="6B7176"/>
-                </a:solidFill>
-                <a:latin typeface="Aptos" pitchFamily="34" charset="0"/>
-                <a:ea typeface="Aptos" pitchFamily="34" charset="-122"/>
-                <a:cs typeface="Aptos" pitchFamily="34" charset="-120"/>
-              </a:rPr>
-              <a:t>Baseline result closely match those found by </a:t>
-            </a:r>
-            <a:r>
-              <a:rPr lang="en-US" sz="850" i="1" dirty="0" err="1">
-                <a:solidFill>
-                  <a:srgbClr val="6B7176"/>
-                </a:solidFill>
-                <a:latin typeface="Aptos" pitchFamily="34" charset="0"/>
-                <a:ea typeface="Aptos" pitchFamily="34" charset="-122"/>
-                <a:cs typeface="Aptos" pitchFamily="34" charset="-120"/>
-              </a:rPr>
-              <a:t>Piczak</a:t>
-            </a:r>
-            <a:endParaRPr lang="en-US" sz="850" dirty="0"/>
           </a:p>
         </p:txBody>
       </p:sp>
@@ -24220,14 +24403,16 @@
         </p:nvSpPr>
         <p:spPr>
           <a:xfrm>
-            <a:off x="731520" y="2321628"/>
+            <a:off x="731520" y="2381772"/>
             <a:ext cx="1627632" cy="164592"/>
           </a:xfrm>
           <a:prstGeom prst="rect">
             <a:avLst/>
           </a:prstGeom>
           <a:noFill/>
-          <a:ln/>
+          <a:ln>
+            <a:noFill/>
+          </a:ln>
         </p:spPr>
         <p:txBody>
           <a:bodyPr wrap="square" lIns="0" tIns="0" rIns="0" bIns="0" rtlCol="0" anchor="t">
@@ -24260,7 +24445,7 @@
         </p:nvSpPr>
         <p:spPr>
           <a:xfrm>
-            <a:off x="731520" y="4326060"/>
+            <a:off x="731520" y="4650734"/>
             <a:ext cx="1002270" cy="146304"/>
           </a:xfrm>
           <a:prstGeom prst="rect">
@@ -24300,7 +24485,7 @@
         </p:nvSpPr>
         <p:spPr>
           <a:xfrm>
-            <a:off x="731520" y="4568476"/>
+            <a:off x="731520" y="4893150"/>
             <a:ext cx="5133821" cy="1281482"/>
           </a:xfrm>
           <a:prstGeom prst="rect">
@@ -32938,13 +33123,13 @@
           <p:nvPr>
             <p:extLst>
               <p:ext uri="{D42A27DB-BD31-4B8C-83A1-F6EECF244321}">
-                <p14:modId xmlns:p14="http://schemas.microsoft.com/office/powerpoint/2010/main" val="2921529174"/>
+                <p14:modId xmlns:p14="http://schemas.microsoft.com/office/powerpoint/2010/main" val="1793188872"/>
               </p:ext>
             </p:extLst>
           </p:nvPr>
         </p:nvGraphicFramePr>
         <p:xfrm>
-          <a:off x="731520" y="4288669"/>
+          <a:off x="731520" y="4328425"/>
           <a:ext cx="4479886" cy="1158240"/>
         </p:xfrm>
         <a:graphic>
@@ -33989,13 +34174,13 @@
           <p:nvPr>
             <p:extLst>
               <p:ext uri="{D42A27DB-BD31-4B8C-83A1-F6EECF244321}">
-                <p14:modId xmlns:p14="http://schemas.microsoft.com/office/powerpoint/2010/main" val="3987419374"/>
+                <p14:modId xmlns:p14="http://schemas.microsoft.com/office/powerpoint/2010/main" val="519187257"/>
               </p:ext>
             </p:extLst>
           </p:nvPr>
         </p:nvGraphicFramePr>
         <p:xfrm>
-          <a:off x="731522" y="5560056"/>
+          <a:off x="731522" y="5639568"/>
           <a:ext cx="4479884" cy="600456"/>
         </p:xfrm>
         <a:graphic>

</xml_diff>

<commit_message>
Updated Transfer Learning Slides
</commit_message>
<xml_diff>
--- a/Docs/Final_Project_Presentation_Draft.pptx
+++ b/Docs/Final_Project_Presentation_Draft.pptx
@@ -4446,7 +4446,7 @@
       </p:sp>
       <p:pic>
         <p:nvPicPr>
-          <p:cNvPr id="28" name="Image 0" descr="/Users/andrew/Library/CloudStorage/OneDrive-CornellUniversity/Courses/SYSEN5888/ Project/DeepLearning5888Project/Code/Transfer Learning/VGGish Results/VGGish_combined_training_test_metrics_1fold_5fold.png"/>
+          <p:cNvPr id="28" name="Image 0"/>
           <p:cNvPicPr>
             <a:picLocks noChangeAspect="1"/>
           </p:cNvPicPr>
@@ -4459,8 +4459,8 @@
         </p:blipFill>
         <p:spPr>
           <a:xfrm>
-            <a:off x="6012932" y="1591056"/>
-            <a:ext cx="5739517" cy="2411187"/>
+            <a:off x="6012932" y="1680632"/>
+            <a:ext cx="5739517" cy="2232034"/>
           </a:xfrm>
           <a:prstGeom prst="rect">
             <a:avLst/>
@@ -5911,631 +5911,6 @@
           </a:graphicData>
         </a:graphic>
       </p:graphicFrame>
-      <p:graphicFrame>
-        <p:nvGraphicFramePr>
-          <p:cNvPr id="64" name="Table 1">
-            <a:extLst>
-              <a:ext uri="{FF2B5EF4-FFF2-40B4-BE49-F238E27FC236}">
-                <a16:creationId xmlns:a16="http://schemas.microsoft.com/office/drawing/2014/main" id="{D91EE508-A360-8F17-6E14-BE218974268F}"/>
-              </a:ext>
-            </a:extLst>
-          </p:cNvPr>
-          <p:cNvGraphicFramePr>
-            <a:graphicFrameLocks noGrp="1"/>
-          </p:cNvGraphicFramePr>
-          <p:nvPr>
-            <p:extLst>
-              <p:ext uri="{D42A27DB-BD31-4B8C-83A1-F6EECF244321}">
-                <p14:modId xmlns:p14="http://schemas.microsoft.com/office/powerpoint/2010/main" val="2101833763"/>
-              </p:ext>
-            </p:extLst>
-          </p:nvPr>
-        </p:nvGraphicFramePr>
-        <p:xfrm>
-          <a:off x="6141156" y="4226223"/>
-          <a:ext cx="4389120" cy="749808"/>
-        </p:xfrm>
-        <a:graphic>
-          <a:graphicData uri="http://schemas.openxmlformats.org/drawingml/2006/table">
-            <a:tbl>
-              <a:tblPr/>
-              <a:tblGrid>
-                <a:gridCol w="2106778">
-                  <a:extLst>
-                    <a:ext uri="{9D8B030D-6E8A-4147-A177-3AD203B41FA5}">
-                      <a16:colId xmlns:a16="http://schemas.microsoft.com/office/drawing/2014/main" val="20000"/>
-                    </a:ext>
-                  </a:extLst>
-                </a:gridCol>
-                <a:gridCol w="1141171">
-                  <a:extLst>
-                    <a:ext uri="{9D8B030D-6E8A-4147-A177-3AD203B41FA5}">
-                      <a16:colId xmlns:a16="http://schemas.microsoft.com/office/drawing/2014/main" val="20001"/>
-                    </a:ext>
-                  </a:extLst>
-                </a:gridCol>
-                <a:gridCol w="1141171">
-                  <a:extLst>
-                    <a:ext uri="{9D8B030D-6E8A-4147-A177-3AD203B41FA5}">
-                      <a16:colId xmlns:a16="http://schemas.microsoft.com/office/drawing/2014/main" val="20002"/>
-                    </a:ext>
-                  </a:extLst>
-                </a:gridCol>
-              </a:tblGrid>
-              <a:tr h="249936">
-                <a:tc>
-                  <a:txBody>
-                    <a:bodyPr/>
-                    <a:lstStyle/>
-                    <a:p>
-                      <a:pPr marL="0" indent="0">
-                        <a:buNone/>
-                      </a:pPr>
-                      <a:r>
-                        <a:rPr lang="en-US" sz="920" b="1" dirty="0">
-                          <a:solidFill>
-                            <a:srgbClr val="FFFFFF"/>
-                          </a:solidFill>
-                        </a:rPr>
-                        <a:t>Variant</a:t>
-                      </a:r>
-                      <a:endParaRPr lang="en-US" sz="920" dirty="0"/>
-                    </a:p>
-                  </a:txBody>
-                  <a:tcPr marL="50292" marR="50292" marT="50292" marB="50292">
-                    <a:lnL w="10160" cap="flat" cmpd="sng" algn="ctr">
-                      <a:solidFill>
-                        <a:srgbClr val="FFFFFF"/>
-                      </a:solidFill>
-                      <a:prstDash val="solid"/>
-                      <a:round/>
-                      <a:headEnd type="none" w="med" len="med"/>
-                      <a:tailEnd type="none" w="med" len="med"/>
-                    </a:lnL>
-                    <a:lnR w="10160" cap="flat" cmpd="sng" algn="ctr">
-                      <a:solidFill>
-                        <a:srgbClr val="FFFFFF"/>
-                      </a:solidFill>
-                      <a:prstDash val="solid"/>
-                      <a:round/>
-                      <a:headEnd type="none" w="med" len="med"/>
-                      <a:tailEnd type="none" w="med" len="med"/>
-                    </a:lnR>
-                    <a:lnT w="10160" cap="flat" cmpd="sng" algn="ctr">
-                      <a:solidFill>
-                        <a:srgbClr val="FFFFFF"/>
-                      </a:solidFill>
-                      <a:prstDash val="solid"/>
-                      <a:round/>
-                      <a:headEnd type="none" w="med" len="med"/>
-                      <a:tailEnd type="none" w="med" len="med"/>
-                    </a:lnT>
-                    <a:lnB w="10160" cap="flat" cmpd="sng" algn="ctr">
-                      <a:solidFill>
-                        <a:srgbClr val="FFFFFF"/>
-                      </a:solidFill>
-                      <a:prstDash val="solid"/>
-                      <a:round/>
-                      <a:headEnd type="none" w="med" len="med"/>
-                      <a:tailEnd type="none" w="med" len="med"/>
-                    </a:lnB>
-                    <a:solidFill>
-                      <a:srgbClr val="17677D"/>
-                    </a:solidFill>
-                  </a:tcPr>
-                </a:tc>
-                <a:tc>
-                  <a:txBody>
-                    <a:bodyPr/>
-                    <a:lstStyle/>
-                    <a:p>
-                      <a:pPr marL="0" indent="0">
-                        <a:buNone/>
-                      </a:pPr>
-                      <a:r>
-                        <a:rPr lang="en-US" sz="920" b="1" dirty="0">
-                          <a:solidFill>
-                            <a:srgbClr val="FFFFFF"/>
-                          </a:solidFill>
-                        </a:rPr>
-                        <a:t>Final</a:t>
-                      </a:r>
-                      <a:endParaRPr lang="en-US" sz="920" dirty="0"/>
-                    </a:p>
-                  </a:txBody>
-                  <a:tcPr marL="50292" marR="50292" marT="50292" marB="50292">
-                    <a:lnL w="10160" cap="flat" cmpd="sng" algn="ctr">
-                      <a:solidFill>
-                        <a:srgbClr val="FFFFFF"/>
-                      </a:solidFill>
-                      <a:prstDash val="solid"/>
-                      <a:round/>
-                      <a:headEnd type="none" w="med" len="med"/>
-                      <a:tailEnd type="none" w="med" len="med"/>
-                    </a:lnL>
-                    <a:lnR w="10160" cap="flat" cmpd="sng" algn="ctr">
-                      <a:solidFill>
-                        <a:srgbClr val="FFFFFF"/>
-                      </a:solidFill>
-                      <a:prstDash val="solid"/>
-                      <a:round/>
-                      <a:headEnd type="none" w="med" len="med"/>
-                      <a:tailEnd type="none" w="med" len="med"/>
-                    </a:lnR>
-                    <a:lnT w="10160" cap="flat" cmpd="sng" algn="ctr">
-                      <a:solidFill>
-                        <a:srgbClr val="FFFFFF"/>
-                      </a:solidFill>
-                      <a:prstDash val="solid"/>
-                      <a:round/>
-                      <a:headEnd type="none" w="med" len="med"/>
-                      <a:tailEnd type="none" w="med" len="med"/>
-                    </a:lnT>
-                    <a:lnB w="10160" cap="flat" cmpd="sng" algn="ctr">
-                      <a:solidFill>
-                        <a:srgbClr val="FFFFFF"/>
-                      </a:solidFill>
-                      <a:prstDash val="solid"/>
-                      <a:round/>
-                      <a:headEnd type="none" w="med" len="med"/>
-                      <a:tailEnd type="none" w="med" len="med"/>
-                    </a:lnB>
-                    <a:solidFill>
-                      <a:srgbClr val="17677D"/>
-                    </a:solidFill>
-                  </a:tcPr>
-                </a:tc>
-                <a:tc>
-                  <a:txBody>
-                    <a:bodyPr/>
-                    <a:lstStyle/>
-                    <a:p>
-                      <a:pPr marL="0" indent="0">
-                        <a:buNone/>
-                      </a:pPr>
-                      <a:r>
-                        <a:rPr lang="en-US" sz="920" b="1" dirty="0">
-                          <a:solidFill>
-                            <a:srgbClr val="FFFFFF"/>
-                          </a:solidFill>
-                        </a:rPr>
-                        <a:t>Best</a:t>
-                      </a:r>
-                      <a:endParaRPr lang="en-US" sz="920" dirty="0"/>
-                    </a:p>
-                  </a:txBody>
-                  <a:tcPr marL="50292" marR="50292" marT="50292" marB="50292">
-                    <a:lnL w="10160" cap="flat" cmpd="sng" algn="ctr">
-                      <a:solidFill>
-                        <a:srgbClr val="FFFFFF"/>
-                      </a:solidFill>
-                      <a:prstDash val="solid"/>
-                      <a:round/>
-                      <a:headEnd type="none" w="med" len="med"/>
-                      <a:tailEnd type="none" w="med" len="med"/>
-                    </a:lnL>
-                    <a:lnR w="10160" cap="flat" cmpd="sng" algn="ctr">
-                      <a:solidFill>
-                        <a:srgbClr val="FFFFFF"/>
-                      </a:solidFill>
-                      <a:prstDash val="solid"/>
-                      <a:round/>
-                      <a:headEnd type="none" w="med" len="med"/>
-                      <a:tailEnd type="none" w="med" len="med"/>
-                    </a:lnR>
-                    <a:lnT w="10160" cap="flat" cmpd="sng" algn="ctr">
-                      <a:solidFill>
-                        <a:srgbClr val="FFFFFF"/>
-                      </a:solidFill>
-                      <a:prstDash val="solid"/>
-                      <a:round/>
-                      <a:headEnd type="none" w="med" len="med"/>
-                      <a:tailEnd type="none" w="med" len="med"/>
-                    </a:lnT>
-                    <a:lnB w="10160" cap="flat" cmpd="sng" algn="ctr">
-                      <a:solidFill>
-                        <a:srgbClr val="FFFFFF"/>
-                      </a:solidFill>
-                      <a:prstDash val="solid"/>
-                      <a:round/>
-                      <a:headEnd type="none" w="med" len="med"/>
-                      <a:tailEnd type="none" w="med" len="med"/>
-                    </a:lnB>
-                    <a:solidFill>
-                      <a:srgbClr val="17677D"/>
-                    </a:solidFill>
-                  </a:tcPr>
-                </a:tc>
-                <a:extLst>
-                  <a:ext uri="{0D108BD9-81ED-4DB2-BD59-A6C34878D82A}">
-                    <a16:rowId xmlns:a16="http://schemas.microsoft.com/office/drawing/2014/main" val="10000"/>
-                  </a:ext>
-                </a:extLst>
-              </a:tr>
-              <a:tr h="249936">
-                <a:tc>
-                  <a:txBody>
-                    <a:bodyPr/>
-                    <a:lstStyle/>
-                    <a:p>
-                      <a:pPr marL="0" indent="0">
-                        <a:buNone/>
-                      </a:pPr>
-                      <a:r>
-                        <a:rPr lang="en-US" sz="870" b="1" dirty="0">
-                          <a:solidFill>
-                            <a:srgbClr val="1F2528"/>
-                          </a:solidFill>
-                        </a:rPr>
-                        <a:t>Frozen</a:t>
-                      </a:r>
-                      <a:endParaRPr lang="en-US" sz="870" dirty="0"/>
-                    </a:p>
-                  </a:txBody>
-                  <a:tcPr marL="50292" marR="50292" marT="50292" marB="50292">
-                    <a:lnL w="10160" cap="flat" cmpd="sng" algn="ctr">
-                      <a:solidFill>
-                        <a:srgbClr val="FFFFFF"/>
-                      </a:solidFill>
-                      <a:prstDash val="solid"/>
-                      <a:round/>
-                      <a:headEnd type="none" w="med" len="med"/>
-                      <a:tailEnd type="none" w="med" len="med"/>
-                    </a:lnL>
-                    <a:lnR w="10160" cap="flat" cmpd="sng" algn="ctr">
-                      <a:solidFill>
-                        <a:srgbClr val="FFFFFF"/>
-                      </a:solidFill>
-                      <a:prstDash val="solid"/>
-                      <a:round/>
-                      <a:headEnd type="none" w="med" len="med"/>
-                      <a:tailEnd type="none" w="med" len="med"/>
-                    </a:lnR>
-                    <a:lnT w="10160" cap="flat" cmpd="sng" algn="ctr">
-                      <a:solidFill>
-                        <a:srgbClr val="FFFFFF"/>
-                      </a:solidFill>
-                      <a:prstDash val="solid"/>
-                      <a:round/>
-                      <a:headEnd type="none" w="med" len="med"/>
-                      <a:tailEnd type="none" w="med" len="med"/>
-                    </a:lnT>
-                    <a:lnB w="10160" cap="flat" cmpd="sng" algn="ctr">
-                      <a:solidFill>
-                        <a:srgbClr val="FFFFFF"/>
-                      </a:solidFill>
-                      <a:prstDash val="solid"/>
-                      <a:round/>
-                      <a:headEnd type="none" w="med" len="med"/>
-                      <a:tailEnd type="none" w="med" len="med"/>
-                    </a:lnB>
-                    <a:solidFill>
-                      <a:srgbClr val="F8FAF8"/>
-                    </a:solidFill>
-                  </a:tcPr>
-                </a:tc>
-                <a:tc>
-                  <a:txBody>
-                    <a:bodyPr/>
-                    <a:lstStyle/>
-                    <a:p>
-                      <a:pPr marL="0" indent="0">
-                        <a:buNone/>
-                      </a:pPr>
-                      <a:r>
-                        <a:rPr lang="en-US" sz="870" dirty="0">
-                          <a:solidFill>
-                            <a:srgbClr val="1F2528"/>
-                          </a:solidFill>
-                        </a:rPr>
-                        <a:t>56.45%</a:t>
-                      </a:r>
-                      <a:endParaRPr lang="en-US" sz="870" dirty="0"/>
-                    </a:p>
-                  </a:txBody>
-                  <a:tcPr marL="50292" marR="50292" marT="50292" marB="50292">
-                    <a:lnL w="10160" cap="flat" cmpd="sng" algn="ctr">
-                      <a:solidFill>
-                        <a:srgbClr val="FFFFFF"/>
-                      </a:solidFill>
-                      <a:prstDash val="solid"/>
-                      <a:round/>
-                      <a:headEnd type="none" w="med" len="med"/>
-                      <a:tailEnd type="none" w="med" len="med"/>
-                    </a:lnL>
-                    <a:lnR w="10160" cap="flat" cmpd="sng" algn="ctr">
-                      <a:solidFill>
-                        <a:srgbClr val="FFFFFF"/>
-                      </a:solidFill>
-                      <a:prstDash val="solid"/>
-                      <a:round/>
-                      <a:headEnd type="none" w="med" len="med"/>
-                      <a:tailEnd type="none" w="med" len="med"/>
-                    </a:lnR>
-                    <a:lnT w="10160" cap="flat" cmpd="sng" algn="ctr">
-                      <a:solidFill>
-                        <a:srgbClr val="FFFFFF"/>
-                      </a:solidFill>
-                      <a:prstDash val="solid"/>
-                      <a:round/>
-                      <a:headEnd type="none" w="med" len="med"/>
-                      <a:tailEnd type="none" w="med" len="med"/>
-                    </a:lnT>
-                    <a:lnB w="10160" cap="flat" cmpd="sng" algn="ctr">
-                      <a:solidFill>
-                        <a:srgbClr val="FFFFFF"/>
-                      </a:solidFill>
-                      <a:prstDash val="solid"/>
-                      <a:round/>
-                      <a:headEnd type="none" w="med" len="med"/>
-                      <a:tailEnd type="none" w="med" len="med"/>
-                    </a:lnB>
-                    <a:solidFill>
-                      <a:srgbClr val="F8FAF8"/>
-                    </a:solidFill>
-                  </a:tcPr>
-                </a:tc>
-                <a:tc>
-                  <a:txBody>
-                    <a:bodyPr/>
-                    <a:lstStyle/>
-                    <a:p>
-                      <a:pPr marL="0" indent="0">
-                        <a:buNone/>
-                      </a:pPr>
-                      <a:r>
-                        <a:rPr lang="en-US" sz="870" dirty="0">
-                          <a:solidFill>
-                            <a:srgbClr val="1F2528"/>
-                          </a:solidFill>
-                        </a:rPr>
-                        <a:t>60.25%</a:t>
-                      </a:r>
-                      <a:endParaRPr lang="en-US" sz="870" dirty="0"/>
-                    </a:p>
-                  </a:txBody>
-                  <a:tcPr marL="50292" marR="50292" marT="50292" marB="50292">
-                    <a:lnL w="10160" cap="flat" cmpd="sng" algn="ctr">
-                      <a:solidFill>
-                        <a:srgbClr val="FFFFFF"/>
-                      </a:solidFill>
-                      <a:prstDash val="solid"/>
-                      <a:round/>
-                      <a:headEnd type="none" w="med" len="med"/>
-                      <a:tailEnd type="none" w="med" len="med"/>
-                    </a:lnL>
-                    <a:lnR w="10160" cap="flat" cmpd="sng" algn="ctr">
-                      <a:solidFill>
-                        <a:srgbClr val="FFFFFF"/>
-                      </a:solidFill>
-                      <a:prstDash val="solid"/>
-                      <a:round/>
-                      <a:headEnd type="none" w="med" len="med"/>
-                      <a:tailEnd type="none" w="med" len="med"/>
-                    </a:lnR>
-                    <a:lnT w="10160" cap="flat" cmpd="sng" algn="ctr">
-                      <a:solidFill>
-                        <a:srgbClr val="FFFFFF"/>
-                      </a:solidFill>
-                      <a:prstDash val="solid"/>
-                      <a:round/>
-                      <a:headEnd type="none" w="med" len="med"/>
-                      <a:tailEnd type="none" w="med" len="med"/>
-                    </a:lnT>
-                    <a:lnB w="10160" cap="flat" cmpd="sng" algn="ctr">
-                      <a:solidFill>
-                        <a:srgbClr val="FFFFFF"/>
-                      </a:solidFill>
-                      <a:prstDash val="solid"/>
-                      <a:round/>
-                      <a:headEnd type="none" w="med" len="med"/>
-                      <a:tailEnd type="none" w="med" len="med"/>
-                    </a:lnB>
-                    <a:solidFill>
-                      <a:srgbClr val="F8FAF8"/>
-                    </a:solidFill>
-                  </a:tcPr>
-                </a:tc>
-                <a:extLst>
-                  <a:ext uri="{0D108BD9-81ED-4DB2-BD59-A6C34878D82A}">
-                    <a16:rowId xmlns:a16="http://schemas.microsoft.com/office/drawing/2014/main" val="10001"/>
-                  </a:ext>
-                </a:extLst>
-              </a:tr>
-              <a:tr h="249936">
-                <a:tc>
-                  <a:txBody>
-                    <a:bodyPr/>
-                    <a:lstStyle/>
-                    <a:p>
-                      <a:pPr marL="0" indent="0">
-                        <a:buNone/>
-                      </a:pPr>
-                      <a:r>
-                        <a:rPr lang="en-US" sz="870" b="1" dirty="0">
-                          <a:solidFill>
-                            <a:srgbClr val="1F2528"/>
-                          </a:solidFill>
-                        </a:rPr>
-                        <a:t>Fine-tuned</a:t>
-                      </a:r>
-                      <a:endParaRPr lang="en-US" sz="870" dirty="0"/>
-                    </a:p>
-                  </a:txBody>
-                  <a:tcPr marL="50292" marR="50292" marT="50292" marB="50292">
-                    <a:lnL w="10160" cap="flat" cmpd="sng" algn="ctr">
-                      <a:solidFill>
-                        <a:srgbClr val="FFFFFF"/>
-                      </a:solidFill>
-                      <a:prstDash val="solid"/>
-                      <a:round/>
-                      <a:headEnd type="none" w="med" len="med"/>
-                      <a:tailEnd type="none" w="med" len="med"/>
-                    </a:lnL>
-                    <a:lnR w="10160" cap="flat" cmpd="sng" algn="ctr">
-                      <a:solidFill>
-                        <a:srgbClr val="FFFFFF"/>
-                      </a:solidFill>
-                      <a:prstDash val="solid"/>
-                      <a:round/>
-                      <a:headEnd type="none" w="med" len="med"/>
-                      <a:tailEnd type="none" w="med" len="med"/>
-                    </a:lnR>
-                    <a:lnT w="10160" cap="flat" cmpd="sng" algn="ctr">
-                      <a:solidFill>
-                        <a:srgbClr val="FFFFFF"/>
-                      </a:solidFill>
-                      <a:prstDash val="solid"/>
-                      <a:round/>
-                      <a:headEnd type="none" w="med" len="med"/>
-                      <a:tailEnd type="none" w="med" len="med"/>
-                    </a:lnT>
-                    <a:lnB w="10160" cap="flat" cmpd="sng" algn="ctr">
-                      <a:solidFill>
-                        <a:srgbClr val="FFFFFF"/>
-                      </a:solidFill>
-                      <a:prstDash val="solid"/>
-                      <a:round/>
-                      <a:headEnd type="none" w="med" len="med"/>
-                      <a:tailEnd type="none" w="med" len="med"/>
-                    </a:lnB>
-                    <a:solidFill>
-                      <a:srgbClr val="EEF2F3"/>
-                    </a:solidFill>
-                  </a:tcPr>
-                </a:tc>
-                <a:tc>
-                  <a:txBody>
-                    <a:bodyPr/>
-                    <a:lstStyle/>
-                    <a:p>
-                      <a:pPr marL="0" indent="0">
-                        <a:buNone/>
-                      </a:pPr>
-                      <a:r>
-                        <a:rPr lang="en-US" sz="870" dirty="0">
-                          <a:solidFill>
-                            <a:srgbClr val="1F2528"/>
-                          </a:solidFill>
-                        </a:rPr>
-                        <a:t>53.15%</a:t>
-                      </a:r>
-                      <a:endParaRPr lang="en-US" sz="870" dirty="0"/>
-                    </a:p>
-                  </a:txBody>
-                  <a:tcPr marL="50292" marR="50292" marT="50292" marB="50292">
-                    <a:lnL w="10160" cap="flat" cmpd="sng" algn="ctr">
-                      <a:solidFill>
-                        <a:srgbClr val="FFFFFF"/>
-                      </a:solidFill>
-                      <a:prstDash val="solid"/>
-                      <a:round/>
-                      <a:headEnd type="none" w="med" len="med"/>
-                      <a:tailEnd type="none" w="med" len="med"/>
-                    </a:lnL>
-                    <a:lnR w="10160" cap="flat" cmpd="sng" algn="ctr">
-                      <a:solidFill>
-                        <a:srgbClr val="FFFFFF"/>
-                      </a:solidFill>
-                      <a:prstDash val="solid"/>
-                      <a:round/>
-                      <a:headEnd type="none" w="med" len="med"/>
-                      <a:tailEnd type="none" w="med" len="med"/>
-                    </a:lnR>
-                    <a:lnT w="10160" cap="flat" cmpd="sng" algn="ctr">
-                      <a:solidFill>
-                        <a:srgbClr val="FFFFFF"/>
-                      </a:solidFill>
-                      <a:prstDash val="solid"/>
-                      <a:round/>
-                      <a:headEnd type="none" w="med" len="med"/>
-                      <a:tailEnd type="none" w="med" len="med"/>
-                    </a:lnT>
-                    <a:lnB w="10160" cap="flat" cmpd="sng" algn="ctr">
-                      <a:solidFill>
-                        <a:srgbClr val="FFFFFF"/>
-                      </a:solidFill>
-                      <a:prstDash val="solid"/>
-                      <a:round/>
-                      <a:headEnd type="none" w="med" len="med"/>
-                      <a:tailEnd type="none" w="med" len="med"/>
-                    </a:lnB>
-                    <a:solidFill>
-                      <a:srgbClr val="EEF2F3"/>
-                    </a:solidFill>
-                  </a:tcPr>
-                </a:tc>
-                <a:tc>
-                  <a:txBody>
-                    <a:bodyPr/>
-                    <a:lstStyle/>
-                    <a:p>
-                      <a:pPr marL="0" indent="0">
-                        <a:buNone/>
-                      </a:pPr>
-                      <a:r>
-                        <a:rPr lang="en-US" sz="870" dirty="0">
-                          <a:solidFill>
-                            <a:srgbClr val="1F2528"/>
-                          </a:solidFill>
-                        </a:rPr>
-                        <a:t>53.50%</a:t>
-                      </a:r>
-                      <a:endParaRPr lang="en-US" sz="870" dirty="0"/>
-                    </a:p>
-                  </a:txBody>
-                  <a:tcPr marL="50292" marR="50292" marT="50292" marB="50292">
-                    <a:lnL w="10160" cap="flat" cmpd="sng" algn="ctr">
-                      <a:solidFill>
-                        <a:srgbClr val="FFFFFF"/>
-                      </a:solidFill>
-                      <a:prstDash val="solid"/>
-                      <a:round/>
-                      <a:headEnd type="none" w="med" len="med"/>
-                      <a:tailEnd type="none" w="med" len="med"/>
-                    </a:lnL>
-                    <a:lnR w="10160" cap="flat" cmpd="sng" algn="ctr">
-                      <a:solidFill>
-                        <a:srgbClr val="FFFFFF"/>
-                      </a:solidFill>
-                      <a:prstDash val="solid"/>
-                      <a:round/>
-                      <a:headEnd type="none" w="med" len="med"/>
-                      <a:tailEnd type="none" w="med" len="med"/>
-                    </a:lnR>
-                    <a:lnT w="10160" cap="flat" cmpd="sng" algn="ctr">
-                      <a:solidFill>
-                        <a:srgbClr val="FFFFFF"/>
-                      </a:solidFill>
-                      <a:prstDash val="solid"/>
-                      <a:round/>
-                      <a:headEnd type="none" w="med" len="med"/>
-                      <a:tailEnd type="none" w="med" len="med"/>
-                    </a:lnT>
-                    <a:lnB w="10160" cap="flat" cmpd="sng" algn="ctr">
-                      <a:solidFill>
-                        <a:srgbClr val="FFFFFF"/>
-                      </a:solidFill>
-                      <a:prstDash val="solid"/>
-                      <a:round/>
-                      <a:headEnd type="none" w="med" len="med"/>
-                      <a:tailEnd type="none" w="med" len="med"/>
-                    </a:lnB>
-                    <a:solidFill>
-                      <a:srgbClr val="EEF2F3"/>
-                    </a:solidFill>
-                  </a:tcPr>
-                </a:tc>
-                <a:extLst>
-                  <a:ext uri="{0D108BD9-81ED-4DB2-BD59-A6C34878D82A}">
-                    <a16:rowId xmlns:a16="http://schemas.microsoft.com/office/drawing/2014/main" val="10002"/>
-                  </a:ext>
-                </a:extLst>
-              </a:tr>
-            </a:tbl>
-          </a:graphicData>
-        </a:graphic>
-      </p:graphicFrame>
       <p:sp>
         <p:nvSpPr>
           <p:cNvPr id="67" name="Text 36">
@@ -6596,8 +5971,8 @@
         </p:nvSpPr>
         <p:spPr>
           <a:xfrm>
-            <a:off x="731520" y="4727447"/>
-            <a:ext cx="3886200" cy="420624"/>
+            <a:off x="731519" y="4727446"/>
+            <a:ext cx="4106203" cy="914400"/>
           </a:xfrm>
           <a:prstGeom prst="rect">
             <a:avLst/>
@@ -6626,7 +6001,7 @@
                 <a:ea typeface="Aptos" pitchFamily="34" charset="-122"/>
                 <a:cs typeface="Aptos" pitchFamily="34" charset="-120"/>
               </a:rPr>
-              <a:t>Pretraining is not automatically enough; representation fit and optimization choices matter.</a:t>
+              <a:t>While training accuracy improved significantly, pretraining is not automatically enough; representation fit and optimization choices matter. Test accuracy performed much lower at 64.5% and 61% for Frozen and Fine-Tuned models respectively</a:t>
             </a:r>
             <a:endParaRPr lang="en-US" sz="1200" dirty="0"/>
           </a:p>
@@ -6704,6 +6079,501 @@
           </a:fontRef>
         </p:style>
       </p:cxnSp>
+      <p:grpSp>
+        <p:nvGrpSpPr>
+          <p:cNvPr id="6" name="Group 5">
+            <a:extLst>
+              <a:ext uri="{FF2B5EF4-FFF2-40B4-BE49-F238E27FC236}">
+                <a16:creationId xmlns:a16="http://schemas.microsoft.com/office/drawing/2014/main" id="{A4CEFFAD-9D45-801C-C7A8-30DC06BBFD52}"/>
+              </a:ext>
+            </a:extLst>
+          </p:cNvPr>
+          <p:cNvGrpSpPr/>
+          <p:nvPr/>
+        </p:nvGrpSpPr>
+        <p:grpSpPr>
+          <a:xfrm>
+            <a:off x="6478524" y="4643132"/>
+            <a:ext cx="1920240" cy="772294"/>
+            <a:chOff x="6957490" y="4123666"/>
+            <a:chExt cx="1920240" cy="772294"/>
+          </a:xfrm>
+        </p:grpSpPr>
+        <p:sp>
+          <p:nvSpPr>
+            <p:cNvPr id="8" name="Shape 48">
+              <a:extLst>
+                <a:ext uri="{FF2B5EF4-FFF2-40B4-BE49-F238E27FC236}">
+                  <a16:creationId xmlns:a16="http://schemas.microsoft.com/office/drawing/2014/main" id="{69167FE1-7828-9BF8-EC1C-81E436E87F49}"/>
+                </a:ext>
+              </a:extLst>
+            </p:cNvPr>
+            <p:cNvSpPr/>
+            <p:nvPr/>
+          </p:nvSpPr>
+          <p:spPr>
+            <a:xfrm>
+              <a:off x="6957490" y="4123666"/>
+              <a:ext cx="1920012" cy="772294"/>
+            </a:xfrm>
+            <a:prstGeom prst="rect">
+              <a:avLst/>
+            </a:prstGeom>
+            <a:solidFill>
+              <a:srgbClr val="FFFFFF">
+                <a:alpha val="98000"/>
+              </a:srgbClr>
+            </a:solidFill>
+            <a:ln w="17780">
+              <a:solidFill>
+                <a:schemeClr val="tx1">
+                  <a:lumMod val="75000"/>
+                  <a:lumOff val="25000"/>
+                </a:schemeClr>
+              </a:solidFill>
+              <a:prstDash val="solid"/>
+            </a:ln>
+          </p:spPr>
+          <p:txBody>
+            <a:bodyPr/>
+            <a:lstStyle/>
+            <a:p>
+              <a:endParaRPr lang="en-US"/>
+            </a:p>
+          </p:txBody>
+        </p:sp>
+        <p:sp>
+          <p:nvSpPr>
+            <p:cNvPr id="9" name="Text 49">
+              <a:extLst>
+                <a:ext uri="{FF2B5EF4-FFF2-40B4-BE49-F238E27FC236}">
+                  <a16:creationId xmlns:a16="http://schemas.microsoft.com/office/drawing/2014/main" id="{6D289ABB-47DB-B86F-5309-B5BF661A6F2E}"/>
+                </a:ext>
+              </a:extLst>
+            </p:cNvPr>
+            <p:cNvSpPr/>
+            <p:nvPr/>
+          </p:nvSpPr>
+          <p:spPr>
+            <a:xfrm>
+              <a:off x="7048930" y="4260826"/>
+              <a:ext cx="1828800" cy="329184"/>
+            </a:xfrm>
+            <a:prstGeom prst="rect">
+              <a:avLst/>
+            </a:prstGeom>
+            <a:noFill/>
+            <a:ln/>
+          </p:spPr>
+          <p:txBody>
+            <a:bodyPr wrap="square" lIns="0" tIns="0" rIns="0" bIns="0" rtlCol="0" anchor="t">
+              <a:normAutofit/>
+            </a:bodyPr>
+            <a:lstStyle/>
+            <a:p>
+              <a:pPr marL="0" indent="0" algn="ctr">
+                <a:lnSpc>
+                  <a:spcPct val="90000"/>
+                </a:lnSpc>
+                <a:buNone/>
+              </a:pPr>
+              <a:r>
+                <a:rPr lang="en-US" sz="2100" b="1" dirty="0">
+                  <a:solidFill>
+                    <a:schemeClr val="tx1">
+                      <a:lumMod val="75000"/>
+                      <a:lumOff val="25000"/>
+                    </a:schemeClr>
+                  </a:solidFill>
+                  <a:latin typeface="Aptos Display" pitchFamily="34" charset="0"/>
+                  <a:ea typeface="Aptos Display" pitchFamily="34" charset="-122"/>
+                  <a:cs typeface="Aptos Display" pitchFamily="34" charset="-120"/>
+                </a:rPr>
+                <a:t>64.5%</a:t>
+              </a:r>
+              <a:endParaRPr lang="en-US" sz="2100" dirty="0">
+                <a:solidFill>
+                  <a:schemeClr val="tx1">
+                    <a:lumMod val="75000"/>
+                    <a:lumOff val="25000"/>
+                  </a:schemeClr>
+                </a:solidFill>
+              </a:endParaRPr>
+            </a:p>
+          </p:txBody>
+        </p:sp>
+        <p:sp>
+          <p:nvSpPr>
+            <p:cNvPr id="12" name="Text 50">
+              <a:extLst>
+                <a:ext uri="{FF2B5EF4-FFF2-40B4-BE49-F238E27FC236}">
+                  <a16:creationId xmlns:a16="http://schemas.microsoft.com/office/drawing/2014/main" id="{27BAB689-CEDE-945D-E10F-92035FA2DED7}"/>
+                </a:ext>
+              </a:extLst>
+            </p:cNvPr>
+            <p:cNvSpPr/>
+            <p:nvPr/>
+          </p:nvSpPr>
+          <p:spPr>
+            <a:xfrm>
+              <a:off x="7067218" y="4654018"/>
+              <a:ext cx="1792224" cy="219456"/>
+            </a:xfrm>
+            <a:prstGeom prst="rect">
+              <a:avLst/>
+            </a:prstGeom>
+            <a:noFill/>
+            <a:ln/>
+          </p:spPr>
+          <p:txBody>
+            <a:bodyPr wrap="square" lIns="0" tIns="0" rIns="0" bIns="0" rtlCol="0" anchor="t">
+              <a:normAutofit/>
+            </a:bodyPr>
+            <a:lstStyle/>
+            <a:p>
+              <a:pPr marL="0" indent="0" algn="ctr">
+                <a:lnSpc>
+                  <a:spcPct val="90000"/>
+                </a:lnSpc>
+                <a:buNone/>
+              </a:pPr>
+              <a:r>
+                <a:rPr lang="en-US" sz="780" dirty="0">
+                  <a:solidFill>
+                    <a:srgbClr val="6B7176"/>
+                  </a:solidFill>
+                  <a:latin typeface="Aptos" pitchFamily="34" charset="0"/>
+                  <a:ea typeface="Aptos" pitchFamily="34" charset="-122"/>
+                  <a:cs typeface="Aptos" pitchFamily="34" charset="-120"/>
+                </a:rPr>
+                <a:t>Piczak published LP clip-level reference</a:t>
+              </a:r>
+              <a:endParaRPr lang="en-US" sz="780" dirty="0"/>
+            </a:p>
+          </p:txBody>
+        </p:sp>
+      </p:grpSp>
+      <p:grpSp>
+        <p:nvGrpSpPr>
+          <p:cNvPr id="16" name="Group 15">
+            <a:extLst>
+              <a:ext uri="{FF2B5EF4-FFF2-40B4-BE49-F238E27FC236}">
+                <a16:creationId xmlns:a16="http://schemas.microsoft.com/office/drawing/2014/main" id="{E6FACAB8-ACFE-75A3-267E-A6CB3F395155}"/>
+              </a:ext>
+            </a:extLst>
+          </p:cNvPr>
+          <p:cNvGrpSpPr/>
+          <p:nvPr/>
+        </p:nvGrpSpPr>
+        <p:grpSpPr>
+          <a:xfrm>
+            <a:off x="9304020" y="4151375"/>
+            <a:ext cx="1965960" cy="914400"/>
+            <a:chOff x="6591302" y="4233671"/>
+            <a:chExt cx="1965960" cy="914400"/>
+          </a:xfrm>
+        </p:grpSpPr>
+        <p:sp>
+          <p:nvSpPr>
+            <p:cNvPr id="17" name="Shape 28">
+              <a:extLst>
+                <a:ext uri="{FF2B5EF4-FFF2-40B4-BE49-F238E27FC236}">
+                  <a16:creationId xmlns:a16="http://schemas.microsoft.com/office/drawing/2014/main" id="{E1AC7B9A-CDB3-C47E-30A5-6AF5336F597A}"/>
+                </a:ext>
+              </a:extLst>
+            </p:cNvPr>
+            <p:cNvSpPr/>
+            <p:nvPr/>
+          </p:nvSpPr>
+          <p:spPr>
+            <a:xfrm>
+              <a:off x="6591302" y="4233671"/>
+              <a:ext cx="1965960" cy="914400"/>
+            </a:xfrm>
+            <a:prstGeom prst="rect">
+              <a:avLst/>
+            </a:prstGeom>
+            <a:solidFill>
+              <a:srgbClr val="FFFFFF">
+                <a:alpha val="98000"/>
+              </a:srgbClr>
+            </a:solidFill>
+            <a:ln w="17780">
+              <a:solidFill>
+                <a:srgbClr val="17677D"/>
+              </a:solidFill>
+              <a:prstDash val="solid"/>
+            </a:ln>
+          </p:spPr>
+          <p:txBody>
+            <a:bodyPr/>
+            <a:lstStyle/>
+            <a:p>
+              <a:endParaRPr lang="en-US"/>
+            </a:p>
+          </p:txBody>
+        </p:sp>
+        <p:sp>
+          <p:nvSpPr>
+            <p:cNvPr id="18" name="Text 29">
+              <a:extLst>
+                <a:ext uri="{FF2B5EF4-FFF2-40B4-BE49-F238E27FC236}">
+                  <a16:creationId xmlns:a16="http://schemas.microsoft.com/office/drawing/2014/main" id="{D864CF10-274C-B463-9F34-CAC2C315EB92}"/>
+                </a:ext>
+              </a:extLst>
+            </p:cNvPr>
+            <p:cNvSpPr/>
+            <p:nvPr/>
+          </p:nvSpPr>
+          <p:spPr>
+            <a:xfrm>
+              <a:off x="6682742" y="4370831"/>
+              <a:ext cx="1783080" cy="329184"/>
+            </a:xfrm>
+            <a:prstGeom prst="rect">
+              <a:avLst/>
+            </a:prstGeom>
+            <a:noFill/>
+            <a:ln/>
+          </p:spPr>
+          <p:txBody>
+            <a:bodyPr wrap="square" lIns="0" tIns="0" rIns="0" bIns="0" rtlCol="0" anchor="t">
+              <a:normAutofit/>
+            </a:bodyPr>
+            <a:lstStyle/>
+            <a:p>
+              <a:pPr algn="ctr">
+                <a:lnSpc>
+                  <a:spcPct val="90000"/>
+                </a:lnSpc>
+              </a:pPr>
+              <a:r>
+                <a:rPr lang="en-US" sz="2100" b="1" dirty="0">
+                  <a:solidFill>
+                    <a:srgbClr val="17677D"/>
+                  </a:solidFill>
+                  <a:latin typeface="Aptos Display" pitchFamily="34" charset="0"/>
+                  <a:ea typeface="Aptos Display" pitchFamily="34" charset="-122"/>
+                  <a:cs typeface="Aptos Display" pitchFamily="34" charset="-120"/>
+                </a:rPr>
+                <a:t>91.69 %</a:t>
+              </a:r>
+              <a:endParaRPr lang="en-US" sz="2100" dirty="0"/>
+            </a:p>
+          </p:txBody>
+        </p:sp>
+        <p:sp>
+          <p:nvSpPr>
+            <p:cNvPr id="19" name="Text 30">
+              <a:extLst>
+                <a:ext uri="{FF2B5EF4-FFF2-40B4-BE49-F238E27FC236}">
+                  <a16:creationId xmlns:a16="http://schemas.microsoft.com/office/drawing/2014/main" id="{3DB68733-04AE-50AF-7D93-336F33B95783}"/>
+                </a:ext>
+              </a:extLst>
+            </p:cNvPr>
+            <p:cNvSpPr/>
+            <p:nvPr/>
+          </p:nvSpPr>
+          <p:spPr>
+            <a:xfrm>
+              <a:off x="6701030" y="4764023"/>
+              <a:ext cx="1746504" cy="219456"/>
+            </a:xfrm>
+            <a:prstGeom prst="rect">
+              <a:avLst/>
+            </a:prstGeom>
+            <a:noFill/>
+            <a:ln/>
+          </p:spPr>
+          <p:txBody>
+            <a:bodyPr wrap="square" lIns="0" tIns="0" rIns="0" bIns="0" rtlCol="0" anchor="t">
+              <a:normAutofit/>
+            </a:bodyPr>
+            <a:lstStyle/>
+            <a:p>
+              <a:pPr marL="0" indent="0" algn="ctr">
+                <a:lnSpc>
+                  <a:spcPct val="90000"/>
+                </a:lnSpc>
+                <a:buNone/>
+              </a:pPr>
+              <a:r>
+                <a:rPr lang="en-US" sz="780" dirty="0">
+                  <a:solidFill>
+                    <a:srgbClr val="6B7176"/>
+                  </a:solidFill>
+                  <a:latin typeface="Aptos" pitchFamily="34" charset="0"/>
+                  <a:ea typeface="Aptos" pitchFamily="34" charset="-122"/>
+                  <a:cs typeface="Aptos" pitchFamily="34" charset="-120"/>
+                </a:rPr>
+                <a:t>Frozen final 5-fold accuracy</a:t>
+              </a:r>
+              <a:endParaRPr lang="en-US" sz="780" dirty="0"/>
+            </a:p>
+          </p:txBody>
+        </p:sp>
+      </p:grpSp>
+      <p:grpSp>
+        <p:nvGrpSpPr>
+          <p:cNvPr id="20" name="Group 19">
+            <a:extLst>
+              <a:ext uri="{FF2B5EF4-FFF2-40B4-BE49-F238E27FC236}">
+                <a16:creationId xmlns:a16="http://schemas.microsoft.com/office/drawing/2014/main" id="{22A2A5F9-F867-8E80-76FD-4F71BE66FB64}"/>
+              </a:ext>
+            </a:extLst>
+          </p:cNvPr>
+          <p:cNvGrpSpPr/>
+          <p:nvPr/>
+        </p:nvGrpSpPr>
+        <p:grpSpPr>
+          <a:xfrm>
+            <a:off x="9304020" y="5304484"/>
+            <a:ext cx="1965960" cy="914400"/>
+            <a:chOff x="6591302" y="4233671"/>
+            <a:chExt cx="1965960" cy="914400"/>
+          </a:xfrm>
+        </p:grpSpPr>
+        <p:sp>
+          <p:nvSpPr>
+            <p:cNvPr id="21" name="Shape 28">
+              <a:extLst>
+                <a:ext uri="{FF2B5EF4-FFF2-40B4-BE49-F238E27FC236}">
+                  <a16:creationId xmlns:a16="http://schemas.microsoft.com/office/drawing/2014/main" id="{E24CA961-B9CA-7003-D39B-D269F1F1A645}"/>
+                </a:ext>
+              </a:extLst>
+            </p:cNvPr>
+            <p:cNvSpPr/>
+            <p:nvPr/>
+          </p:nvSpPr>
+          <p:spPr>
+            <a:xfrm>
+              <a:off x="6591302" y="4233671"/>
+              <a:ext cx="1965960" cy="914400"/>
+            </a:xfrm>
+            <a:prstGeom prst="rect">
+              <a:avLst/>
+            </a:prstGeom>
+            <a:solidFill>
+              <a:srgbClr val="FFFFFF">
+                <a:alpha val="98000"/>
+              </a:srgbClr>
+            </a:solidFill>
+            <a:ln w="17780">
+              <a:solidFill>
+                <a:srgbClr val="17677D"/>
+              </a:solidFill>
+              <a:prstDash val="solid"/>
+            </a:ln>
+          </p:spPr>
+          <p:txBody>
+            <a:bodyPr/>
+            <a:lstStyle/>
+            <a:p>
+              <a:endParaRPr lang="en-US"/>
+            </a:p>
+          </p:txBody>
+        </p:sp>
+        <p:sp>
+          <p:nvSpPr>
+            <p:cNvPr id="22" name="Text 29">
+              <a:extLst>
+                <a:ext uri="{FF2B5EF4-FFF2-40B4-BE49-F238E27FC236}">
+                  <a16:creationId xmlns:a16="http://schemas.microsoft.com/office/drawing/2014/main" id="{0ABD6622-FB29-2444-526C-BF6D3C09651D}"/>
+                </a:ext>
+              </a:extLst>
+            </p:cNvPr>
+            <p:cNvSpPr/>
+            <p:nvPr/>
+          </p:nvSpPr>
+          <p:spPr>
+            <a:xfrm>
+              <a:off x="6682742" y="4370831"/>
+              <a:ext cx="1783080" cy="329184"/>
+            </a:xfrm>
+            <a:prstGeom prst="rect">
+              <a:avLst/>
+            </a:prstGeom>
+            <a:noFill/>
+            <a:ln/>
+          </p:spPr>
+          <p:txBody>
+            <a:bodyPr wrap="square" lIns="0" tIns="0" rIns="0" bIns="0" rtlCol="0" anchor="t">
+              <a:normAutofit/>
+            </a:bodyPr>
+            <a:lstStyle/>
+            <a:p>
+              <a:pPr marL="0" indent="0" algn="ctr">
+                <a:lnSpc>
+                  <a:spcPct val="90000"/>
+                </a:lnSpc>
+                <a:buNone/>
+              </a:pPr>
+              <a:r>
+                <a:rPr lang="en-US" sz="2100" b="1" dirty="0">
+                  <a:solidFill>
+                    <a:srgbClr val="17677D"/>
+                  </a:solidFill>
+                  <a:latin typeface="Aptos Display" pitchFamily="34" charset="0"/>
+                  <a:ea typeface="Aptos Display" pitchFamily="34" charset="-122"/>
+                  <a:cs typeface="Aptos Display" pitchFamily="34" charset="-120"/>
+                </a:rPr>
+                <a:t>82.94%</a:t>
+              </a:r>
+              <a:endParaRPr lang="en-US" sz="2100" dirty="0"/>
+            </a:p>
+          </p:txBody>
+        </p:sp>
+        <p:sp>
+          <p:nvSpPr>
+            <p:cNvPr id="23" name="Text 30">
+              <a:extLst>
+                <a:ext uri="{FF2B5EF4-FFF2-40B4-BE49-F238E27FC236}">
+                  <a16:creationId xmlns:a16="http://schemas.microsoft.com/office/drawing/2014/main" id="{953D72EA-447D-8B97-7A06-AEBD6885B938}"/>
+                </a:ext>
+              </a:extLst>
+            </p:cNvPr>
+            <p:cNvSpPr/>
+            <p:nvPr/>
+          </p:nvSpPr>
+          <p:spPr>
+            <a:xfrm>
+              <a:off x="6701030" y="4764023"/>
+              <a:ext cx="1746504" cy="219456"/>
+            </a:xfrm>
+            <a:prstGeom prst="rect">
+              <a:avLst/>
+            </a:prstGeom>
+            <a:noFill/>
+            <a:ln/>
+          </p:spPr>
+          <p:txBody>
+            <a:bodyPr wrap="square" lIns="0" tIns="0" rIns="0" bIns="0" rtlCol="0" anchor="t">
+              <a:normAutofit/>
+            </a:bodyPr>
+            <a:lstStyle/>
+            <a:p>
+              <a:pPr marL="0" indent="0" algn="ctr">
+                <a:lnSpc>
+                  <a:spcPct val="90000"/>
+                </a:lnSpc>
+                <a:buNone/>
+              </a:pPr>
+              <a:r>
+                <a:rPr lang="en-US" sz="780" dirty="0">
+                  <a:solidFill>
+                    <a:srgbClr val="6B7176"/>
+                  </a:solidFill>
+                  <a:latin typeface="Aptos" pitchFamily="34" charset="0"/>
+                  <a:ea typeface="Aptos" pitchFamily="34" charset="-122"/>
+                  <a:cs typeface="Aptos" pitchFamily="34" charset="-120"/>
+                </a:rPr>
+                <a:t>Fine-tuned final 5-fold accuracy</a:t>
+              </a:r>
+              <a:endParaRPr lang="en-US" sz="780" dirty="0"/>
+            </a:p>
+          </p:txBody>
+        </p:sp>
+      </p:grpSp>
     </p:spTree>
   </p:cSld>
   <p:clrMapOvr>
@@ -7067,175 +6937,152 @@
           </a:p>
         </p:txBody>
       </p:sp>
-      <p:sp>
-        <p:nvSpPr>
-          <p:cNvPr id="30" name="Shape 28"/>
-          <p:cNvSpPr/>
-          <p:nvPr/>
-        </p:nvSpPr>
-        <p:spPr>
-          <a:xfrm>
-            <a:off x="6591302" y="4233671"/>
+      <p:grpSp>
+        <p:nvGrpSpPr>
+          <p:cNvPr id="8" name="Group 7">
+            <a:extLst>
+              <a:ext uri="{FF2B5EF4-FFF2-40B4-BE49-F238E27FC236}">
+                <a16:creationId xmlns:a16="http://schemas.microsoft.com/office/drawing/2014/main" id="{672A12AB-EF7E-3CB7-A9A9-0B88F8D0872D}"/>
+              </a:ext>
+            </a:extLst>
+          </p:cNvPr>
+          <p:cNvGrpSpPr/>
+          <p:nvPr/>
+        </p:nvGrpSpPr>
+        <p:grpSpPr>
+          <a:xfrm>
+            <a:off x="9445278" y="5423641"/>
             <a:ext cx="1965960" cy="914400"/>
-          </a:xfrm>
-          <a:prstGeom prst="rect">
-            <a:avLst/>
-          </a:prstGeom>
-          <a:solidFill>
-            <a:srgbClr val="FFFFFF">
-              <a:alpha val="98000"/>
-            </a:srgbClr>
-          </a:solidFill>
-          <a:ln w="17780">
+            <a:chOff x="6591302" y="4233671"/>
+            <a:chExt cx="1965960" cy="914400"/>
+          </a:xfrm>
+        </p:grpSpPr>
+        <p:sp>
+          <p:nvSpPr>
+            <p:cNvPr id="30" name="Shape 28"/>
+            <p:cNvSpPr/>
+            <p:nvPr/>
+          </p:nvSpPr>
+          <p:spPr>
+            <a:xfrm>
+              <a:off x="6591302" y="4233671"/>
+              <a:ext cx="1965960" cy="914400"/>
+            </a:xfrm>
+            <a:prstGeom prst="rect">
+              <a:avLst/>
+            </a:prstGeom>
             <a:solidFill>
-              <a:srgbClr val="17677D"/>
+              <a:srgbClr val="FFFFFF">
+                <a:alpha val="98000"/>
+              </a:srgbClr>
             </a:solidFill>
-            <a:prstDash val="solid"/>
-          </a:ln>
-        </p:spPr>
-        <p:txBody>
-          <a:bodyPr/>
-          <a:lstStyle/>
-          <a:p>
-            <a:endParaRPr lang="en-US"/>
-          </a:p>
-        </p:txBody>
-      </p:sp>
-      <p:sp>
-        <p:nvSpPr>
-          <p:cNvPr id="31" name="Text 29"/>
-          <p:cNvSpPr/>
-          <p:nvPr/>
-        </p:nvSpPr>
-        <p:spPr>
-          <a:xfrm>
-            <a:off x="6682742" y="4370831"/>
-            <a:ext cx="1783080" cy="329184"/>
-          </a:xfrm>
-          <a:prstGeom prst="rect">
-            <a:avLst/>
-          </a:prstGeom>
-          <a:noFill/>
-          <a:ln/>
-        </p:spPr>
-        <p:txBody>
-          <a:bodyPr wrap="square" lIns="0" tIns="0" rIns="0" bIns="0" rtlCol="0" anchor="t">
-            <a:normAutofit/>
-          </a:bodyPr>
-          <a:lstStyle/>
-          <a:p>
-            <a:pPr marL="0" indent="0" algn="ctr">
-              <a:lnSpc>
-                <a:spcPct val="90000"/>
-              </a:lnSpc>
-              <a:buNone/>
-            </a:pPr>
-            <a:r>
-              <a:rPr lang="en-US" sz="2100" b="1" dirty="0">
-                <a:solidFill>
-                  <a:srgbClr val="17677D"/>
-                </a:solidFill>
-                <a:latin typeface="Aptos Display" pitchFamily="34" charset="0"/>
-                <a:ea typeface="Aptos Display" pitchFamily="34" charset="-122"/>
-                <a:cs typeface="Aptos Display" pitchFamily="34" charset="-120"/>
-              </a:rPr>
-              <a:t>83.4%</a:t>
-            </a:r>
-            <a:endParaRPr lang="en-US" sz="2100" dirty="0"/>
-          </a:p>
-        </p:txBody>
-      </p:sp>
-      <p:sp>
-        <p:nvSpPr>
-          <p:cNvPr id="32" name="Text 30"/>
-          <p:cNvSpPr/>
-          <p:nvPr/>
-        </p:nvSpPr>
-        <p:spPr>
-          <a:xfrm>
-            <a:off x="6701030" y="4764023"/>
-            <a:ext cx="1746504" cy="219456"/>
-          </a:xfrm>
-          <a:prstGeom prst="rect">
-            <a:avLst/>
-          </a:prstGeom>
-          <a:noFill/>
-          <a:ln/>
-        </p:spPr>
-        <p:txBody>
-          <a:bodyPr wrap="square" lIns="0" tIns="0" rIns="0" bIns="0" rtlCol="0" anchor="t">
-            <a:normAutofit/>
-          </a:bodyPr>
-          <a:lstStyle/>
-          <a:p>
-            <a:pPr marL="0" indent="0" algn="ctr">
-              <a:lnSpc>
-                <a:spcPct val="90000"/>
-              </a:lnSpc>
-              <a:buNone/>
-            </a:pPr>
-            <a:r>
-              <a:rPr lang="en-US" sz="780" dirty="0">
-                <a:solidFill>
-                  <a:srgbClr val="6B7176"/>
-                </a:solidFill>
-                <a:latin typeface="Aptos" pitchFamily="34" charset="0"/>
-                <a:ea typeface="Aptos" pitchFamily="34" charset="-122"/>
-                <a:cs typeface="Aptos" pitchFamily="34" charset="-120"/>
-              </a:rPr>
-              <a:t>fine-tuned final 5-fold accuracy</a:t>
-            </a:r>
-            <a:endParaRPr lang="en-US" sz="780" dirty="0"/>
-          </a:p>
-        </p:txBody>
-      </p:sp>
-      <p:sp>
-        <p:nvSpPr>
-          <p:cNvPr id="33" name="Text 31"/>
-          <p:cNvSpPr/>
-          <p:nvPr/>
-        </p:nvSpPr>
-        <p:spPr>
-          <a:xfrm>
-            <a:off x="8785862" y="4562855"/>
-            <a:ext cx="3154680" cy="274320"/>
-          </a:xfrm>
-          <a:prstGeom prst="rect">
-            <a:avLst/>
-          </a:prstGeom>
-          <a:noFill/>
-          <a:ln/>
-        </p:spPr>
-        <p:txBody>
-          <a:bodyPr wrap="square" lIns="0" tIns="0" rIns="0" bIns="0" rtlCol="0" anchor="t">
-            <a:normAutofit/>
-          </a:bodyPr>
-          <a:lstStyle/>
-          <a:p>
-            <a:pPr marL="0" indent="0" algn="l">
-              <a:lnSpc>
-                <a:spcPct val="82000"/>
-              </a:lnSpc>
-              <a:buNone/>
-            </a:pPr>
-            <a:r>
-              <a:rPr lang="en-US" sz="850" i="1" dirty="0">
-                <a:solidFill>
-                  <a:srgbClr val="6B7176"/>
-                </a:solidFill>
-                <a:latin typeface="Aptos" pitchFamily="34" charset="0"/>
-                <a:ea typeface="Aptos" pitchFamily="34" charset="-122"/>
-                <a:cs typeface="Aptos" pitchFamily="34" charset="-120"/>
-              </a:rPr>
-              <a:t>Best: 84.45%. First large jump in the current results.</a:t>
-            </a:r>
-            <a:endParaRPr lang="en-US" sz="850" dirty="0"/>
-          </a:p>
-        </p:txBody>
-      </p:sp>
+            <a:ln w="17780">
+              <a:solidFill>
+                <a:srgbClr val="17677D"/>
+              </a:solidFill>
+              <a:prstDash val="solid"/>
+            </a:ln>
+          </p:spPr>
+          <p:txBody>
+            <a:bodyPr/>
+            <a:lstStyle/>
+            <a:p>
+              <a:endParaRPr lang="en-US"/>
+            </a:p>
+          </p:txBody>
+        </p:sp>
+        <p:sp>
+          <p:nvSpPr>
+            <p:cNvPr id="31" name="Text 29"/>
+            <p:cNvSpPr/>
+            <p:nvPr/>
+          </p:nvSpPr>
+          <p:spPr>
+            <a:xfrm>
+              <a:off x="6682742" y="4370831"/>
+              <a:ext cx="1783080" cy="329184"/>
+            </a:xfrm>
+            <a:prstGeom prst="rect">
+              <a:avLst/>
+            </a:prstGeom>
+            <a:noFill/>
+            <a:ln/>
+          </p:spPr>
+          <p:txBody>
+            <a:bodyPr wrap="square" lIns="0" tIns="0" rIns="0" bIns="0" rtlCol="0" anchor="t">
+              <a:normAutofit/>
+            </a:bodyPr>
+            <a:lstStyle/>
+            <a:p>
+              <a:pPr marL="0" indent="0" algn="ctr">
+                <a:lnSpc>
+                  <a:spcPct val="90000"/>
+                </a:lnSpc>
+                <a:buNone/>
+              </a:pPr>
+              <a:r>
+                <a:rPr lang="en-US" sz="2100" b="1" dirty="0">
+                  <a:solidFill>
+                    <a:srgbClr val="17677D"/>
+                  </a:solidFill>
+                  <a:latin typeface="Aptos Display" pitchFamily="34" charset="0"/>
+                  <a:ea typeface="Aptos Display" pitchFamily="34" charset="-122"/>
+                  <a:cs typeface="Aptos Display" pitchFamily="34" charset="-120"/>
+                </a:rPr>
+                <a:t>91.56%</a:t>
+              </a:r>
+              <a:endParaRPr lang="en-US" sz="2100" dirty="0"/>
+            </a:p>
+          </p:txBody>
+        </p:sp>
+        <p:sp>
+          <p:nvSpPr>
+            <p:cNvPr id="32" name="Text 30"/>
+            <p:cNvSpPr/>
+            <p:nvPr/>
+          </p:nvSpPr>
+          <p:spPr>
+            <a:xfrm>
+              <a:off x="6701030" y="4764023"/>
+              <a:ext cx="1746504" cy="219456"/>
+            </a:xfrm>
+            <a:prstGeom prst="rect">
+              <a:avLst/>
+            </a:prstGeom>
+            <a:noFill/>
+            <a:ln/>
+          </p:spPr>
+          <p:txBody>
+            <a:bodyPr wrap="square" lIns="0" tIns="0" rIns="0" bIns="0" rtlCol="0" anchor="t">
+              <a:normAutofit/>
+            </a:bodyPr>
+            <a:lstStyle/>
+            <a:p>
+              <a:pPr marL="0" indent="0" algn="ctr">
+                <a:lnSpc>
+                  <a:spcPct val="90000"/>
+                </a:lnSpc>
+                <a:buNone/>
+              </a:pPr>
+              <a:r>
+                <a:rPr lang="en-US" sz="780" dirty="0">
+                  <a:solidFill>
+                    <a:srgbClr val="6B7176"/>
+                  </a:solidFill>
+                  <a:latin typeface="Aptos" pitchFamily="34" charset="0"/>
+                  <a:ea typeface="Aptos" pitchFamily="34" charset="-122"/>
+                  <a:cs typeface="Aptos" pitchFamily="34" charset="-120"/>
+                </a:rPr>
+                <a:t>Fine-tuned final 5-fold accuracy</a:t>
+              </a:r>
+              <a:endParaRPr lang="en-US" sz="780" dirty="0"/>
+            </a:p>
+          </p:txBody>
+        </p:sp>
+      </p:grpSp>
       <p:pic>
         <p:nvPicPr>
-          <p:cNvPr id="34" name="Image 0" descr="/Users/andrew/Library/CloudStorage/OneDrive-CornellUniversity/Courses/SYSEN5888/ Project/DeepLearning5888Project/Code/Transfer Learning/YAMNet Results/YAMNet_combined_training_test_metrics_1fold_5fold.png"/>
+          <p:cNvPr id="34" name="Image 0"/>
           <p:cNvPicPr>
             <a:picLocks noChangeAspect="1"/>
           </p:cNvPicPr>
@@ -7248,8 +7095,8 @@
         </p:blipFill>
         <p:spPr>
           <a:xfrm>
-            <a:off x="6309359" y="1591056"/>
-            <a:ext cx="5442459" cy="2411188"/>
+            <a:off x="6309359" y="1738394"/>
+            <a:ext cx="5442459" cy="2116511"/>
           </a:xfrm>
           <a:prstGeom prst="rect">
             <a:avLst/>
@@ -8761,7 +8608,7 @@
         <p:spPr>
           <a:xfrm>
             <a:off x="731520" y="4727447"/>
-            <a:ext cx="3886200" cy="420624"/>
+            <a:ext cx="3886200" cy="745690"/>
           </a:xfrm>
           <a:prstGeom prst="rect">
             <a:avLst/>
@@ -8771,7 +8618,7 @@
         </p:spPr>
         <p:txBody>
           <a:bodyPr wrap="square" lIns="0" tIns="0" rIns="0" bIns="0" rtlCol="0" anchor="t">
-            <a:normAutofit fontScale="92500"/>
+            <a:normAutofit lnSpcReduction="10000"/>
           </a:bodyPr>
           <a:lstStyle/>
           <a:p>
@@ -8790,12 +8637,357 @@
                 <a:ea typeface="Aptos" pitchFamily="34" charset="-122"/>
                 <a:cs typeface="Aptos" pitchFamily="34" charset="-120"/>
               </a:rPr>
-              <a:t>Transfer learning quality matters: a stronger domain-pretrained model moves the result well beyond the from-scratch range.</a:t>
+              <a:t>Transfer learning quality matters: a stronger domain-pretrained model moves the result well beyond the from-scratch range. Transfer learning on large pretrained models can pose overfitting issues that can negatively affect the </a:t>
+            </a:r>
+            <a:r>
+              <a:rPr lang="en-US" sz="1200">
+                <a:solidFill>
+                  <a:srgbClr val="1F2528"/>
+                </a:solidFill>
+                <a:latin typeface="Aptos" pitchFamily="34" charset="0"/>
+                <a:ea typeface="Aptos" pitchFamily="34" charset="-122"/>
+                <a:cs typeface="Aptos" pitchFamily="34" charset="-120"/>
+              </a:rPr>
+              <a:t>prediction results.</a:t>
             </a:r>
             <a:endParaRPr lang="en-US" sz="1200" dirty="0"/>
           </a:p>
         </p:txBody>
       </p:sp>
+      <p:grpSp>
+        <p:nvGrpSpPr>
+          <p:cNvPr id="9" name="Group 8">
+            <a:extLst>
+              <a:ext uri="{FF2B5EF4-FFF2-40B4-BE49-F238E27FC236}">
+                <a16:creationId xmlns:a16="http://schemas.microsoft.com/office/drawing/2014/main" id="{EC11A150-702D-1BD7-50AF-2A91160EF965}"/>
+              </a:ext>
+            </a:extLst>
+          </p:cNvPr>
+          <p:cNvGrpSpPr/>
+          <p:nvPr/>
+        </p:nvGrpSpPr>
+        <p:grpSpPr>
+          <a:xfrm>
+            <a:off x="9445278" y="4279339"/>
+            <a:ext cx="1965960" cy="914400"/>
+            <a:chOff x="6591302" y="4233671"/>
+            <a:chExt cx="1965960" cy="914400"/>
+          </a:xfrm>
+        </p:grpSpPr>
+        <p:sp>
+          <p:nvSpPr>
+            <p:cNvPr id="10" name="Shape 28">
+              <a:extLst>
+                <a:ext uri="{FF2B5EF4-FFF2-40B4-BE49-F238E27FC236}">
+                  <a16:creationId xmlns:a16="http://schemas.microsoft.com/office/drawing/2014/main" id="{FB84920A-AE94-A236-9389-7EBD5029FF29}"/>
+                </a:ext>
+              </a:extLst>
+            </p:cNvPr>
+            <p:cNvSpPr/>
+            <p:nvPr/>
+          </p:nvSpPr>
+          <p:spPr>
+            <a:xfrm>
+              <a:off x="6591302" y="4233671"/>
+              <a:ext cx="1965960" cy="914400"/>
+            </a:xfrm>
+            <a:prstGeom prst="rect">
+              <a:avLst/>
+            </a:prstGeom>
+            <a:solidFill>
+              <a:srgbClr val="FFFFFF">
+                <a:alpha val="98000"/>
+              </a:srgbClr>
+            </a:solidFill>
+            <a:ln w="17780">
+              <a:solidFill>
+                <a:srgbClr val="17677D"/>
+              </a:solidFill>
+              <a:prstDash val="solid"/>
+            </a:ln>
+          </p:spPr>
+          <p:txBody>
+            <a:bodyPr/>
+            <a:lstStyle/>
+            <a:p>
+              <a:endParaRPr lang="en-US"/>
+            </a:p>
+          </p:txBody>
+        </p:sp>
+        <p:sp>
+          <p:nvSpPr>
+            <p:cNvPr id="12" name="Text 29">
+              <a:extLst>
+                <a:ext uri="{FF2B5EF4-FFF2-40B4-BE49-F238E27FC236}">
+                  <a16:creationId xmlns:a16="http://schemas.microsoft.com/office/drawing/2014/main" id="{1FD27D74-43B3-C445-5AEA-6D61007ECDFB}"/>
+                </a:ext>
+              </a:extLst>
+            </p:cNvPr>
+            <p:cNvSpPr/>
+            <p:nvPr/>
+          </p:nvSpPr>
+          <p:spPr>
+            <a:xfrm>
+              <a:off x="6682742" y="4370831"/>
+              <a:ext cx="1783080" cy="329184"/>
+            </a:xfrm>
+            <a:prstGeom prst="rect">
+              <a:avLst/>
+            </a:prstGeom>
+            <a:noFill/>
+            <a:ln/>
+          </p:spPr>
+          <p:txBody>
+            <a:bodyPr wrap="square" lIns="0" tIns="0" rIns="0" bIns="0" rtlCol="0" anchor="t">
+              <a:normAutofit/>
+            </a:bodyPr>
+            <a:lstStyle/>
+            <a:p>
+              <a:pPr algn="ctr">
+                <a:lnSpc>
+                  <a:spcPct val="90000"/>
+                </a:lnSpc>
+              </a:pPr>
+              <a:r>
+                <a:rPr lang="en-US" sz="2100" b="1" dirty="0">
+                  <a:solidFill>
+                    <a:srgbClr val="17677D"/>
+                  </a:solidFill>
+                  <a:latin typeface="Aptos Display" pitchFamily="34" charset="0"/>
+                  <a:ea typeface="Aptos Display" pitchFamily="34" charset="-122"/>
+                  <a:cs typeface="Aptos Display" pitchFamily="34" charset="-120"/>
+                </a:rPr>
+                <a:t>99.81 %</a:t>
+              </a:r>
+              <a:endParaRPr lang="en-US" sz="2100" dirty="0"/>
+            </a:p>
+          </p:txBody>
+        </p:sp>
+        <p:sp>
+          <p:nvSpPr>
+            <p:cNvPr id="15" name="Text 30">
+              <a:extLst>
+                <a:ext uri="{FF2B5EF4-FFF2-40B4-BE49-F238E27FC236}">
+                  <a16:creationId xmlns:a16="http://schemas.microsoft.com/office/drawing/2014/main" id="{0FC1132F-D57A-0F3C-B724-262B5D617A35}"/>
+                </a:ext>
+              </a:extLst>
+            </p:cNvPr>
+            <p:cNvSpPr/>
+            <p:nvPr/>
+          </p:nvSpPr>
+          <p:spPr>
+            <a:xfrm>
+              <a:off x="6701030" y="4764023"/>
+              <a:ext cx="1746504" cy="219456"/>
+            </a:xfrm>
+            <a:prstGeom prst="rect">
+              <a:avLst/>
+            </a:prstGeom>
+            <a:noFill/>
+            <a:ln/>
+          </p:spPr>
+          <p:txBody>
+            <a:bodyPr wrap="square" lIns="0" tIns="0" rIns="0" bIns="0" rtlCol="0" anchor="t">
+              <a:normAutofit/>
+            </a:bodyPr>
+            <a:lstStyle/>
+            <a:p>
+              <a:pPr marL="0" indent="0" algn="ctr">
+                <a:lnSpc>
+                  <a:spcPct val="90000"/>
+                </a:lnSpc>
+                <a:buNone/>
+              </a:pPr>
+              <a:r>
+                <a:rPr lang="en-US" sz="780" dirty="0">
+                  <a:solidFill>
+                    <a:srgbClr val="6B7176"/>
+                  </a:solidFill>
+                  <a:latin typeface="Aptos" pitchFamily="34" charset="0"/>
+                  <a:ea typeface="Aptos" pitchFamily="34" charset="-122"/>
+                  <a:cs typeface="Aptos" pitchFamily="34" charset="-120"/>
+                </a:rPr>
+                <a:t>Frozen final 5-fold accuracy</a:t>
+              </a:r>
+              <a:endParaRPr lang="en-US" sz="780" dirty="0"/>
+            </a:p>
+          </p:txBody>
+        </p:sp>
+      </p:grpSp>
+      <p:grpSp>
+        <p:nvGrpSpPr>
+          <p:cNvPr id="16" name="Group 15">
+            <a:extLst>
+              <a:ext uri="{FF2B5EF4-FFF2-40B4-BE49-F238E27FC236}">
+                <a16:creationId xmlns:a16="http://schemas.microsoft.com/office/drawing/2014/main" id="{C74D935F-EECB-7141-019C-F85ADD7C5441}"/>
+              </a:ext>
+            </a:extLst>
+          </p:cNvPr>
+          <p:cNvGrpSpPr/>
+          <p:nvPr/>
+        </p:nvGrpSpPr>
+        <p:grpSpPr>
+          <a:xfrm>
+            <a:off x="6693408" y="4723329"/>
+            <a:ext cx="1920240" cy="772294"/>
+            <a:chOff x="6957490" y="4123666"/>
+            <a:chExt cx="1920240" cy="772294"/>
+          </a:xfrm>
+        </p:grpSpPr>
+        <p:sp>
+          <p:nvSpPr>
+            <p:cNvPr id="17" name="Shape 48">
+              <a:extLst>
+                <a:ext uri="{FF2B5EF4-FFF2-40B4-BE49-F238E27FC236}">
+                  <a16:creationId xmlns:a16="http://schemas.microsoft.com/office/drawing/2014/main" id="{538F25B8-A34D-F019-ADB8-AFE6860C1027}"/>
+                </a:ext>
+              </a:extLst>
+            </p:cNvPr>
+            <p:cNvSpPr/>
+            <p:nvPr/>
+          </p:nvSpPr>
+          <p:spPr>
+            <a:xfrm>
+              <a:off x="6957490" y="4123666"/>
+              <a:ext cx="1920012" cy="772294"/>
+            </a:xfrm>
+            <a:prstGeom prst="rect">
+              <a:avLst/>
+            </a:prstGeom>
+            <a:solidFill>
+              <a:srgbClr val="FFFFFF">
+                <a:alpha val="98000"/>
+              </a:srgbClr>
+            </a:solidFill>
+            <a:ln w="17780">
+              <a:solidFill>
+                <a:schemeClr val="tx1">
+                  <a:lumMod val="75000"/>
+                  <a:lumOff val="25000"/>
+                </a:schemeClr>
+              </a:solidFill>
+              <a:prstDash val="solid"/>
+            </a:ln>
+          </p:spPr>
+          <p:txBody>
+            <a:bodyPr/>
+            <a:lstStyle/>
+            <a:p>
+              <a:endParaRPr lang="en-US"/>
+            </a:p>
+          </p:txBody>
+        </p:sp>
+        <p:sp>
+          <p:nvSpPr>
+            <p:cNvPr id="18" name="Text 49">
+              <a:extLst>
+                <a:ext uri="{FF2B5EF4-FFF2-40B4-BE49-F238E27FC236}">
+                  <a16:creationId xmlns:a16="http://schemas.microsoft.com/office/drawing/2014/main" id="{47B2762C-0B40-0FE3-A143-DA1B74EA64DD}"/>
+                </a:ext>
+              </a:extLst>
+            </p:cNvPr>
+            <p:cNvSpPr/>
+            <p:nvPr/>
+          </p:nvSpPr>
+          <p:spPr>
+            <a:xfrm>
+              <a:off x="7048930" y="4260826"/>
+              <a:ext cx="1828800" cy="329184"/>
+            </a:xfrm>
+            <a:prstGeom prst="rect">
+              <a:avLst/>
+            </a:prstGeom>
+            <a:noFill/>
+            <a:ln/>
+          </p:spPr>
+          <p:txBody>
+            <a:bodyPr wrap="square" lIns="0" tIns="0" rIns="0" bIns="0" rtlCol="0" anchor="t">
+              <a:normAutofit/>
+            </a:bodyPr>
+            <a:lstStyle/>
+            <a:p>
+              <a:pPr marL="0" indent="0" algn="ctr">
+                <a:lnSpc>
+                  <a:spcPct val="90000"/>
+                </a:lnSpc>
+                <a:buNone/>
+              </a:pPr>
+              <a:r>
+                <a:rPr lang="en-US" sz="2100" b="1" dirty="0">
+                  <a:solidFill>
+                    <a:schemeClr val="tx1">
+                      <a:lumMod val="75000"/>
+                      <a:lumOff val="25000"/>
+                    </a:schemeClr>
+                  </a:solidFill>
+                  <a:latin typeface="Aptos Display" pitchFamily="34" charset="0"/>
+                  <a:ea typeface="Aptos Display" pitchFamily="34" charset="-122"/>
+                  <a:cs typeface="Aptos Display" pitchFamily="34" charset="-120"/>
+                </a:rPr>
+                <a:t>64.5%</a:t>
+              </a:r>
+              <a:endParaRPr lang="en-US" sz="2100" dirty="0">
+                <a:solidFill>
+                  <a:schemeClr val="tx1">
+                    <a:lumMod val="75000"/>
+                    <a:lumOff val="25000"/>
+                  </a:schemeClr>
+                </a:solidFill>
+              </a:endParaRPr>
+            </a:p>
+          </p:txBody>
+        </p:sp>
+        <p:sp>
+          <p:nvSpPr>
+            <p:cNvPr id="19" name="Text 50">
+              <a:extLst>
+                <a:ext uri="{FF2B5EF4-FFF2-40B4-BE49-F238E27FC236}">
+                  <a16:creationId xmlns:a16="http://schemas.microsoft.com/office/drawing/2014/main" id="{0F5B0046-B2BA-66ED-B4E1-18EDAC4C69EF}"/>
+                </a:ext>
+              </a:extLst>
+            </p:cNvPr>
+            <p:cNvSpPr/>
+            <p:nvPr/>
+          </p:nvSpPr>
+          <p:spPr>
+            <a:xfrm>
+              <a:off x="7067218" y="4654018"/>
+              <a:ext cx="1792224" cy="219456"/>
+            </a:xfrm>
+            <a:prstGeom prst="rect">
+              <a:avLst/>
+            </a:prstGeom>
+            <a:noFill/>
+            <a:ln/>
+          </p:spPr>
+          <p:txBody>
+            <a:bodyPr wrap="square" lIns="0" tIns="0" rIns="0" bIns="0" rtlCol="0" anchor="t">
+              <a:normAutofit/>
+            </a:bodyPr>
+            <a:lstStyle/>
+            <a:p>
+              <a:pPr marL="0" indent="0" algn="ctr">
+                <a:lnSpc>
+                  <a:spcPct val="90000"/>
+                </a:lnSpc>
+                <a:buNone/>
+              </a:pPr>
+              <a:r>
+                <a:rPr lang="en-US" sz="780" dirty="0">
+                  <a:solidFill>
+                    <a:srgbClr val="6B7176"/>
+                  </a:solidFill>
+                  <a:latin typeface="Aptos" pitchFamily="34" charset="0"/>
+                  <a:ea typeface="Aptos" pitchFamily="34" charset="-122"/>
+                  <a:cs typeface="Aptos" pitchFamily="34" charset="-120"/>
+                </a:rPr>
+                <a:t>Piczak published LP clip-level reference</a:t>
+              </a:r>
+              <a:endParaRPr lang="en-US" sz="780" dirty="0"/>
+            </a:p>
+          </p:txBody>
+        </p:sp>
+      </p:grpSp>
     </p:spTree>
   </p:cSld>
   <p:clrMapOvr>

</xml_diff>